<commit_message>
Add PC logger slide, timeline, and footnote on progress deck
- New slide: placeholder for a logger-window screenshot
- New timeline slide running Oct 7 to Dec 2 (last day of classes)
- Footnote explaining the missing 4.85 Hz down-current reading
  (that session only logged one full run)

Co-Authored-By: Claude Sonnet 5 <noreply@anthropic.com>
Claude-Session: https://claude.ai/code/session_01KDBgZS5sBDtdZcqbVDmcN3
</commit_message>
<xml_diff>
--- a/docs/Capstone_Progress_Update.pptx
+++ b/docs/Capstone_Progress_Update.pptx
@@ -13,9 +13,11 @@
     <p:sldId id="261" r:id="rId7"/>
     <p:sldId id="262" r:id="rId8"/>
     <p:sldId id="263" r:id="rId9"/>
+    <p:sldId id="264" r:id="rId10"/>
+    <p:sldId id="265" r:id="rId11"/>
   </p:sldIdLst>
   <p:notesMasterIdLst>
-    <p:notesMasterId r:id="rId10"/>
+    <p:notesMasterId r:id="rId12"/>
   </p:notesMasterIdLst>
   <p:sldSz cx="12192000" cy="6858000"/>
   <p:notesSz cx="6858000" cy="12192000"/>
@@ -551,6 +553,94 @@
 </p:notes>
 </file>
 
+<file path=ppt/notesSlides/notesSlide10.xml><?xml version="1.0" encoding="utf-8"?>
+<p:notes xmlns:a="http://schemas.openxmlformats.org/drawingml/2006/main" xmlns:r="http://schemas.openxmlformats.org/officeDocument/2006/relationships" xmlns:p="http://schemas.openxmlformats.org/presentationml/2006/main">
+  <p:cSld>
+    <p:spTree>
+      <p:nvGrpSpPr>
+        <p:cNvPr id="1" name=""/>
+        <p:cNvGrpSpPr/>
+        <p:nvPr/>
+      </p:nvGrpSpPr>
+      <p:grpSpPr>
+        <a:xfrm>
+          <a:off x="0" y="0"/>
+          <a:ext cx="0" cy="0"/>
+          <a:chOff x="0" y="0"/>
+          <a:chExt cx="0" cy="0"/>
+        </a:xfrm>
+      </p:grpSpPr>
+      <p:sp>
+        <p:nvSpPr>
+          <p:cNvPr id="2" name="Slide Image Placeholder 1"/>
+          <p:cNvSpPr>
+            <a:spLocks noGrp="1" noRot="1" noChangeAspect="1"/>
+          </p:cNvSpPr>
+          <p:nvPr>
+            <p:ph type="sldImg"/>
+          </p:nvPr>
+        </p:nvSpPr>
+        <p:spPr/>
+      </p:sp>
+      <p:sp>
+        <p:nvSpPr>
+          <p:cNvPr id="3" name="Notes Placeholder 2"/>
+          <p:cNvSpPr>
+            <a:spLocks noGrp="1"/>
+          </p:cNvSpPr>
+          <p:nvPr>
+            <p:ph type="body" idx="1"/>
+          </p:nvPr>
+        </p:nvSpPr>
+        <p:spPr/>
+        <p:txBody>
+          <a:bodyPr/>
+          <a:lstStyle/>
+          <a:p>
+            <a:r>
+              <a:rPr lang="en-US" dirty="0"/>
+              <a:t/>
+            </a:r>
+            <a:endParaRPr lang="en-US" dirty="0"/>
+          </a:p>
+        </p:txBody>
+      </p:sp>
+      <p:sp>
+        <p:nvSpPr>
+          <p:cNvPr id="4" name="Slide Number Placeholder 3"/>
+          <p:cNvSpPr>
+            <a:spLocks noGrp="1"/>
+          </p:cNvSpPr>
+          <p:nvPr>
+            <p:ph type="sldNum" sz="quarter" idx="10"/>
+          </p:nvPr>
+        </p:nvSpPr>
+        <p:spPr/>
+        <p:txBody>
+          <a:bodyPr/>
+          <a:lstStyle/>
+          <a:p>
+            <a:fld id="{F7021451-1387-4CA6-816F-3879F97B5CBC}" type="slidenum">
+              <a:rPr lang="en-US"/>
+              <a:t>10</a:t>
+            </a:fld>
+            <a:endParaRPr lang="en-US"/>
+          </a:p>
+        </p:txBody>
+      </p:sp>
+    </p:spTree>
+    <p:extLst>
+      <p:ext uri="{BB962C8B-B14F-4D97-AF65-F5344CB8AC3E}">
+        <p14:creationId xmlns:p14="http://schemas.microsoft.com/office/powerpoint/2010/main" val="1024086991"/>
+      </p:ext>
+    </p:extLst>
+  </p:cSld>
+  <p:clrMapOvr>
+    <a:masterClrMapping/>
+  </p:clrMapOvr>
+</p:notes>
+</file>
+
 <file path=ppt/notesSlides/notesSlide2.xml><?xml version="1.0" encoding="utf-8"?>
 <p:notes xmlns:a="http://schemas.openxmlformats.org/drawingml/2006/main" xmlns:r="http://schemas.openxmlformats.org/officeDocument/2006/relationships" xmlns:p="http://schemas.openxmlformats.org/presentationml/2006/main">
   <p:cSld>
@@ -1149,6 +1239,94 @@
             <a:fld id="{F7021451-1387-4CA6-816F-3879F97B5CBC}" type="slidenum">
               <a:rPr lang="en-US"/>
               <a:t>8</a:t>
+            </a:fld>
+            <a:endParaRPr lang="en-US"/>
+          </a:p>
+        </p:txBody>
+      </p:sp>
+    </p:spTree>
+    <p:extLst>
+      <p:ext uri="{BB962C8B-B14F-4D97-AF65-F5344CB8AC3E}">
+        <p14:creationId xmlns:p14="http://schemas.microsoft.com/office/powerpoint/2010/main" val="1024086991"/>
+      </p:ext>
+    </p:extLst>
+  </p:cSld>
+  <p:clrMapOvr>
+    <a:masterClrMapping/>
+  </p:clrMapOvr>
+</p:notes>
+</file>
+
+<file path=ppt/notesSlides/notesSlide9.xml><?xml version="1.0" encoding="utf-8"?>
+<p:notes xmlns:a="http://schemas.openxmlformats.org/drawingml/2006/main" xmlns:r="http://schemas.openxmlformats.org/officeDocument/2006/relationships" xmlns:p="http://schemas.openxmlformats.org/presentationml/2006/main">
+  <p:cSld>
+    <p:spTree>
+      <p:nvGrpSpPr>
+        <p:cNvPr id="1" name=""/>
+        <p:cNvGrpSpPr/>
+        <p:nvPr/>
+      </p:nvGrpSpPr>
+      <p:grpSpPr>
+        <a:xfrm>
+          <a:off x="0" y="0"/>
+          <a:ext cx="0" cy="0"/>
+          <a:chOff x="0" y="0"/>
+          <a:chExt cx="0" cy="0"/>
+        </a:xfrm>
+      </p:grpSpPr>
+      <p:sp>
+        <p:nvSpPr>
+          <p:cNvPr id="2" name="Slide Image Placeholder 1"/>
+          <p:cNvSpPr>
+            <a:spLocks noGrp="1" noRot="1" noChangeAspect="1"/>
+          </p:cNvSpPr>
+          <p:nvPr>
+            <p:ph type="sldImg"/>
+          </p:nvPr>
+        </p:nvSpPr>
+        <p:spPr/>
+      </p:sp>
+      <p:sp>
+        <p:nvSpPr>
+          <p:cNvPr id="3" name="Notes Placeholder 2"/>
+          <p:cNvSpPr>
+            <a:spLocks noGrp="1"/>
+          </p:cNvSpPr>
+          <p:nvPr>
+            <p:ph type="body" idx="1"/>
+          </p:nvPr>
+        </p:nvSpPr>
+        <p:spPr/>
+        <p:txBody>
+          <a:bodyPr/>
+          <a:lstStyle/>
+          <a:p>
+            <a:r>
+              <a:rPr lang="en-US" dirty="0"/>
+              <a:t/>
+            </a:r>
+            <a:endParaRPr lang="en-US" dirty="0"/>
+          </a:p>
+        </p:txBody>
+      </p:sp>
+      <p:sp>
+        <p:nvSpPr>
+          <p:cNvPr id="4" name="Slide Number Placeholder 3"/>
+          <p:cNvSpPr>
+            <a:spLocks noGrp="1"/>
+          </p:cNvSpPr>
+          <p:nvPr>
+            <p:ph type="sldNum" sz="quarter" idx="10"/>
+          </p:nvPr>
+        </p:nvSpPr>
+        <p:spPr/>
+        <p:txBody>
+          <a:bodyPr/>
+          <a:lstStyle/>
+          <a:p>
+            <a:fld id="{F7021451-1387-4CA6-816F-3879F97B5CBC}" type="slidenum">
+              <a:rPr lang="en-US"/>
+              <a:t>9</a:t>
             </a:fld>
             <a:endParaRPr lang="en-US"/>
           </a:p>
@@ -1734,6 +1912,109 @@
 </p:sld>
 </file>
 
+<file path=ppt/slides/slide10.xml><?xml version="1.0" encoding="utf-8"?>
+<p:sld xmlns:a="http://schemas.openxmlformats.org/drawingml/2006/main" xmlns:r="http://schemas.openxmlformats.org/officeDocument/2006/relationships" xmlns:p="http://schemas.openxmlformats.org/presentationml/2006/main">
+  <p:cSld name="Slide 10">
+    <p:spTree>
+      <p:nvGrpSpPr>
+        <p:cNvPr id="1" name=""/>
+        <p:cNvGrpSpPr/>
+        <p:nvPr/>
+      </p:nvGrpSpPr>
+      <p:grpSpPr>
+        <a:xfrm>
+          <a:off x="0" y="0"/>
+          <a:ext cx="0" cy="0"/>
+          <a:chOff x="0" y="0"/>
+          <a:chExt cx="0" cy="0"/>
+        </a:xfrm>
+      </p:grpSpPr>
+      <p:sp>
+        <p:nvSpPr>
+          <p:cNvPr id="2" name="Text 0"/>
+          <p:cNvSpPr txBox="1"/>
+          <p:nvPr/>
+        </p:nvSpPr>
+        <p:spPr>
+          <a:xfrm>
+            <a:off x="548640" y="2880360"/>
+            <a:ext cx="11091672" cy="914400"/>
+          </a:xfrm>
+          <a:prstGeom prst="rect">
+            <a:avLst/>
+          </a:prstGeom>
+          <a:noFill/>
+          <a:ln/>
+        </p:spPr>
+        <p:txBody>
+          <a:bodyPr wrap="square" rtlCol="0" anchor="ctr"/>
+          <a:lstStyle/>
+          <a:p>
+            <a:pPr algn="l" indent="0" marL="0">
+              <a:buNone/>
+            </a:pPr>
+            <a:r>
+              <a:rPr lang="en-US" sz="3200" b="1" dirty="0">
+                <a:solidFill>
+                  <a:srgbClr val="000000"/>
+                </a:solidFill>
+                <a:latin typeface="Calibri" pitchFamily="34" charset="0"/>
+                <a:ea typeface="Calibri" pitchFamily="34" charset="-122"/>
+                <a:cs typeface="Calibri" pitchFamily="34" charset="-120"/>
+              </a:rPr>
+              <a:t>Questions?</a:t>
+            </a:r>
+            <a:endParaRPr lang="en-US" sz="3200" dirty="0"/>
+          </a:p>
+        </p:txBody>
+      </p:sp>
+      <p:sp>
+        <p:nvSpPr>
+          <p:cNvPr id="3" name="Text 1"/>
+          <p:cNvSpPr txBox="1"/>
+          <p:nvPr/>
+        </p:nvSpPr>
+        <p:spPr>
+          <a:xfrm>
+            <a:off x="11457432" y="6446520"/>
+            <a:ext cx="457200" cy="274320"/>
+          </a:xfrm>
+          <a:prstGeom prst="rect">
+            <a:avLst/>
+          </a:prstGeom>
+          <a:noFill/>
+          <a:ln/>
+        </p:spPr>
+        <p:txBody>
+          <a:bodyPr wrap="square" rtlCol="0" anchor="ctr"/>
+          <a:lstStyle/>
+          <a:p>
+            <a:pPr algn="r" indent="0" marL="0">
+              <a:buNone/>
+            </a:pPr>
+            <a:r>
+              <a:rPr lang="en-US" sz="1000" dirty="0">
+                <a:solidFill>
+                  <a:srgbClr val="595959"/>
+                </a:solidFill>
+                <a:latin typeface="Calibri" pitchFamily="34" charset="0"/>
+                <a:ea typeface="Calibri" pitchFamily="34" charset="-122"/>
+                <a:cs typeface="Calibri" pitchFamily="34" charset="-120"/>
+              </a:rPr>
+              <a:t>10</a:t>
+            </a:r>
+            <a:endParaRPr lang="en-US" sz="1000" dirty="0"/>
+          </a:p>
+        </p:txBody>
+      </p:sp>
+    </p:spTree>
+  </p:cSld>
+  <p:clrMapOvr>
+    <a:masterClrMapping/>
+  </p:clrMapOvr>
+</p:sld>
+</file>
+
 <file path=ppt/slides/slide2.xml><?xml version="1.0" encoding="utf-8"?>
 <p:sld xmlns:a="http://schemas.openxmlformats.org/drawingml/2006/main" xmlns:r="http://schemas.openxmlformats.org/officeDocument/2006/relationships" xmlns:p="http://schemas.openxmlformats.org/presentationml/2006/main">
   <p:cSld name="Slide 2">
@@ -2450,7 +2731,7 @@
                 <a:ea typeface="Calibri" pitchFamily="34" charset="-122"/>
                 <a:cs typeface="Calibri" pitchFamily="34" charset="-120"/>
               </a:rPr>
-              <a:t>Status — Completed</a:t>
+              <a:t>PC Logger — Live Data</a:t>
             </a:r>
             <a:endParaRPr lang="en-US" sz="2800" dirty="0"/>
           </a:p>
@@ -2465,7 +2746,7 @@
         <p:spPr>
           <a:xfrm>
             <a:off x="548640" y="1463040"/>
-            <a:ext cx="11091672" cy="4754880"/>
+            <a:ext cx="5120640" cy="4389120"/>
           </a:xfrm>
           <a:prstGeom prst="rect">
             <a:avLst/>
@@ -2493,7 +2774,7 @@
                 <a:ea typeface="Calibri" pitchFamily="34" charset="-122"/>
                 <a:cs typeface="Calibri" pitchFamily="34" charset="-120"/>
               </a:rPr>
-              <a:t>VFD configured and verified for potentiometer speed control (VFDCHECK: 8/8 settings pass)</a:t>
+              <a:t>Each logged row: time, output frequency, synchronous speed, shaft RPM, slip, output current, known load, test ID</a:t>
             </a:r>
             <a:endParaRPr lang="en-US" sz="1700" dirty="0"/>
           </a:p>
@@ -2514,7 +2795,7 @@
                 <a:ea typeface="Calibri" pitchFamily="34" charset="-122"/>
                 <a:cs typeface="Calibri" pitchFamily="34" charset="-120"/>
               </a:rPr>
-              <a:t>RS-485 / Modbus RTU communication to the VFD confirmed (output frequency + output current registers)</a:t>
+              <a:t>Every motor run is saved automatically to its own file; a summary file collects one line per run</a:t>
             </a:r>
             <a:endParaRPr lang="en-US" sz="1700" dirty="0"/>
           </a:p>
@@ -2535,78 +2816,79 @@
                 <a:ea typeface="Calibri" pitchFamily="34" charset="-122"/>
                 <a:cs typeface="Calibri" pitchFamily="34" charset="-120"/>
               </a:rPr>
-              <a:t>STM32 firmware: logs frequency, current, synchronous speed, and slip every 250 ms; TEST/STOP test sessions with steady-state averaging</a:t>
+              <a:t>The logger prompts for the shaft RPM reading after each run</a:t>
             </a:r>
             <a:endParaRPr lang="en-US" sz="1700" dirty="0"/>
           </a:p>
-          <a:p>
-            <a:pPr marL="228600" indent="-228600">
-              <a:spcAft>
-                <a:spcPts val="1200"/>
-              </a:spcAft>
-              <a:buSzPct val="100000"/>
-              <a:buChar char="•"/>
+        </p:txBody>
+      </p:sp>
+      <p:sp>
+        <p:nvSpPr>
+          <p:cNvPr id="4" name="Shape 2"/>
+          <p:cNvSpPr/>
+          <p:nvPr/>
+        </p:nvSpPr>
+        <p:spPr>
+          <a:xfrm>
+            <a:off x="6400800" y="1463040"/>
+            <a:ext cx="5239512" cy="4206240"/>
+          </a:xfrm>
+          <a:prstGeom prst="rect">
+            <a:avLst/>
+          </a:prstGeom>
+          <a:solidFill>
+            <a:srgbClr val="FFFFFF"/>
+          </a:solidFill>
+          <a:ln w="15875">
+            <a:solidFill>
+              <a:srgbClr val="D9D9D9"/>
+            </a:solidFill>
+            <a:prstDash val="dash"/>
+          </a:ln>
+        </p:spPr>
+      </p:sp>
+      <p:sp>
+        <p:nvSpPr>
+          <p:cNvPr id="5" name="Text 3"/>
+          <p:cNvSpPr txBox="1"/>
+          <p:nvPr/>
+        </p:nvSpPr>
+        <p:spPr>
+          <a:xfrm>
+            <a:off x="6400800" y="1463040"/>
+            <a:ext cx="5239512" cy="4206240"/>
+          </a:xfrm>
+          <a:prstGeom prst="rect">
+            <a:avLst/>
+          </a:prstGeom>
+          <a:noFill/>
+          <a:ln/>
+        </p:spPr>
+        <p:txBody>
+          <a:bodyPr wrap="square" rtlCol="0" anchor="ctr"/>
+          <a:lstStyle/>
+          <a:p>
+            <a:pPr algn="ctr" indent="0" marL="0">
+              <a:buNone/>
             </a:pPr>
             <a:r>
-              <a:rPr lang="en-US" sz="1700" dirty="0">
+              <a:rPr lang="en-US" sz="1400" i="1" dirty="0">
                 <a:solidFill>
-                  <a:srgbClr val="000000"/>
+                  <a:srgbClr val="595959"/>
                 </a:solidFill>
                 <a:latin typeface="Calibri" pitchFamily="34" charset="0"/>
                 <a:ea typeface="Calibri" pitchFamily="34" charset="-122"/>
                 <a:cs typeface="Calibri" pitchFamily="34" charset="-120"/>
               </a:rPr>
-              <a:t>PC logger (Python): automatically saves every motor run and prompts for the shaft RPM reading</a:t>
-            </a:r>
-            <a:endParaRPr lang="en-US" sz="1700" dirty="0"/>
-          </a:p>
-          <a:p>
-            <a:pPr marL="228600" indent="-228600">
-              <a:spcAft>
-                <a:spcPts val="1200"/>
-              </a:spcAft>
-              <a:buSzPct val="100000"/>
-              <a:buChar char="•"/>
-            </a:pPr>
-            <a:r>
-              <a:rPr lang="en-US" sz="1700" dirty="0">
-                <a:solidFill>
-                  <a:srgbClr val="000000"/>
-                </a:solidFill>
-                <a:latin typeface="Calibri" pitchFamily="34" charset="0"/>
-                <a:ea typeface="Calibri" pitchFamily="34" charset="-122"/>
-                <a:cs typeface="Calibri" pitchFamily="34" charset="-120"/>
-              </a:rPr>
-              <a:t>No-load baseline data collected at four speeds (1.39, 2.44, 4.85, 6.36 Hz); 6.36 Hz selected as the fixed calibration speed</a:t>
-            </a:r>
-            <a:endParaRPr lang="en-US" sz="1700" dirty="0"/>
-          </a:p>
-          <a:p>
-            <a:pPr marL="228600" indent="-228600">
-              <a:spcAft>
-                <a:spcPts val="1200"/>
-              </a:spcAft>
-              <a:buSzPct val="100000"/>
-              <a:buChar char="•"/>
-            </a:pPr>
-            <a:r>
-              <a:rPr lang="en-US" sz="1700" dirty="0">
-                <a:solidFill>
-                  <a:srgbClr val="000000"/>
-                </a:solidFill>
-                <a:latin typeface="Calibri" pitchFamily="34" charset="0"/>
-                <a:ea typeface="Calibri" pitchFamily="34" charset="-122"/>
-                <a:cs typeface="Calibri" pitchFamily="34" charset="-120"/>
-              </a:rPr>
-              <a:t>Baseline results documented in a written report, traceable back to every source data file</a:t>
-            </a:r>
-            <a:endParaRPr lang="en-US" sz="1700" dirty="0"/>
+              <a:t>Insert screenshot of logger window</a:t>
+            </a:r>
+            <a:endParaRPr lang="en-US" sz="1400" dirty="0"/>
           </a:p>
         </p:txBody>
       </p:sp>
       <p:sp>
         <p:nvSpPr>
-          <p:cNvPr id="4" name="Text 2"/>
+          <p:cNvPr id="6" name="Text 4"/>
           <p:cNvSpPr txBox="1"/>
           <p:nvPr/>
         </p:nvSpPr>
@@ -2701,7 +2983,7 @@
                 <a:ea typeface="Calibri" pitchFamily="34" charset="-122"/>
                 <a:cs typeface="Calibri" pitchFamily="34" charset="-120"/>
               </a:rPr>
-              <a:t>Status — Not Yet Complete</a:t>
+              <a:t>Status — Completed</a:t>
             </a:r>
             <a:endParaRPr lang="en-US" sz="2800" dirty="0"/>
           </a:p>
@@ -2730,13 +3012,13 @@
           <a:p>
             <a:pPr marL="228600" indent="-228600">
               <a:spcAft>
-                <a:spcPts val="1600"/>
+                <a:spcPts val="1200"/>
               </a:spcAft>
               <a:buSzPct val="100000"/>
               <a:buChar char="•"/>
             </a:pPr>
             <a:r>
-              <a:rPr lang="en-US" sz="1900" dirty="0">
+              <a:rPr lang="en-US" sz="1700" dirty="0">
                 <a:solidFill>
                   <a:srgbClr val="000000"/>
                 </a:solidFill>
@@ -2744,20 +3026,20 @@
                 <a:ea typeface="Calibri" pitchFamily="34" charset="-122"/>
                 <a:cs typeface="Calibri" pitchFamily="34" charset="-120"/>
               </a:rPr>
-              <a:t>Weighted-load calibration runs — the data needed to actually build the predictive model</a:t>
-            </a:r>
-            <a:endParaRPr lang="en-US" sz="1900" dirty="0"/>
+              <a:t>VFD configured and verified for potentiometer speed control (VFDCHECK: 8/8 settings pass)</a:t>
+            </a:r>
+            <a:endParaRPr lang="en-US" sz="1700" dirty="0"/>
           </a:p>
           <a:p>
             <a:pPr marL="228600" indent="-228600">
               <a:spcAft>
-                <a:spcPts val="1600"/>
+                <a:spcPts val="1200"/>
               </a:spcAft>
               <a:buSzPct val="100000"/>
               <a:buChar char="•"/>
             </a:pPr>
             <a:r>
-              <a:rPr lang="en-US" sz="1900" dirty="0">
+              <a:rPr lang="en-US" sz="1700" dirty="0">
                 <a:solidFill>
                   <a:srgbClr val="000000"/>
                 </a:solidFill>
@@ -2765,20 +3047,20 @@
                 <a:ea typeface="Calibri" pitchFamily="34" charset="-122"/>
                 <a:cs typeface="Calibri" pitchFamily="34" charset="-120"/>
               </a:rPr>
-              <a:t>Keypad + HMI integration on the controller (data entry, predicted load/speed display)</a:t>
-            </a:r>
-            <a:endParaRPr lang="en-US" sz="1900" dirty="0"/>
+              <a:t>RS-485 / Modbus RTU communication to the VFD confirmed (output frequency + output current registers)</a:t>
+            </a:r>
+            <a:endParaRPr lang="en-US" sz="1700" dirty="0"/>
           </a:p>
           <a:p>
             <a:pPr marL="228600" indent="-228600">
               <a:spcAft>
-                <a:spcPts val="1600"/>
+                <a:spcPts val="1200"/>
               </a:spcAft>
               <a:buSzPct val="100000"/>
               <a:buChar char="•"/>
             </a:pPr>
             <a:r>
-              <a:rPr lang="en-US" sz="1900" dirty="0">
+              <a:rPr lang="en-US" sz="1700" dirty="0">
                 <a:solidFill>
                   <a:srgbClr val="000000"/>
                 </a:solidFill>
@@ -2786,20 +3068,20 @@
                 <a:ea typeface="Calibri" pitchFamily="34" charset="-122"/>
                 <a:cs typeface="Calibri" pitchFamily="34" charset="-120"/>
               </a:rPr>
-              <a:t>Predictive model: fit and validate slip-to-load and current-to-load estimates</a:t>
-            </a:r>
-            <a:endParaRPr lang="en-US" sz="1900" dirty="0"/>
+              <a:t>STM32 firmware: logs frequency, current, synchronous speed, and slip every 250 ms; TEST/STOP test sessions with steady-state averaging</a:t>
+            </a:r>
+            <a:endParaRPr lang="en-US" sz="1700" dirty="0"/>
           </a:p>
           <a:p>
             <a:pPr marL="228600" indent="-228600">
               <a:spcAft>
-                <a:spcPts val="1600"/>
+                <a:spcPts val="1200"/>
               </a:spcAft>
               <a:buSzPct val="100000"/>
               <a:buChar char="•"/>
             </a:pPr>
             <a:r>
-              <a:rPr lang="en-US" sz="1900" dirty="0">
+              <a:rPr lang="en-US" sz="1700" dirty="0">
                 <a:solidFill>
                   <a:srgbClr val="000000"/>
                 </a:solidFill>
@@ -2807,20 +3089,20 @@
                 <a:ea typeface="Calibri" pitchFamily="34" charset="-122"/>
                 <a:cs typeface="Calibri" pitchFamily="34" charset="-120"/>
               </a:rPr>
-              <a:t>Short conference-formatted paper</a:t>
-            </a:r>
-            <a:endParaRPr lang="en-US" sz="1900" dirty="0"/>
+              <a:t>PC logger (Python): automatically saves every motor run and prompts for the shaft RPM reading</a:t>
+            </a:r>
+            <a:endParaRPr lang="en-US" sz="1700" dirty="0"/>
           </a:p>
           <a:p>
             <a:pPr marL="228600" indent="-228600">
               <a:spcAft>
-                <a:spcPts val="1600"/>
+                <a:spcPts val="1200"/>
               </a:spcAft>
               <a:buSzPct val="100000"/>
               <a:buChar char="•"/>
             </a:pPr>
             <a:r>
-              <a:rPr lang="en-US" sz="1900" dirty="0">
+              <a:rPr lang="en-US" sz="1700" dirty="0">
                 <a:solidFill>
                   <a:srgbClr val="000000"/>
                 </a:solidFill>
@@ -2828,9 +3110,30 @@
                 <a:ea typeface="Calibri" pitchFamily="34" charset="-122"/>
                 <a:cs typeface="Calibri" pitchFamily="34" charset="-120"/>
               </a:rPr>
-              <a:t>Final presentation to faculty</a:t>
-            </a:r>
-            <a:endParaRPr lang="en-US" sz="1900" dirty="0"/>
+              <a:t>No-load baseline data collected at four speeds (1.39, 2.44, 4.85, 6.36 Hz); 6.36 Hz selected as the fixed calibration speed</a:t>
+            </a:r>
+            <a:endParaRPr lang="en-US" sz="1700" dirty="0"/>
+          </a:p>
+          <a:p>
+            <a:pPr marL="228600" indent="-228600">
+              <a:spcAft>
+                <a:spcPts val="1200"/>
+              </a:spcAft>
+              <a:buSzPct val="100000"/>
+              <a:buChar char="•"/>
+            </a:pPr>
+            <a:r>
+              <a:rPr lang="en-US" sz="1700" dirty="0">
+                <a:solidFill>
+                  <a:srgbClr val="000000"/>
+                </a:solidFill>
+                <a:latin typeface="Calibri" pitchFamily="34" charset="0"/>
+                <a:ea typeface="Calibri" pitchFamily="34" charset="-122"/>
+                <a:cs typeface="Calibri" pitchFamily="34" charset="-120"/>
+              </a:rPr>
+              <a:t>Baseline results documented in a written report, traceable back to every source data file</a:t>
+            </a:r>
+            <a:endParaRPr lang="en-US" sz="1700" dirty="0"/>
           </a:p>
         </p:txBody>
       </p:sp>
@@ -2931,6 +3234,236 @@
                 <a:ea typeface="Calibri" pitchFamily="34" charset="-122"/>
                 <a:cs typeface="Calibri" pitchFamily="34" charset="-120"/>
               </a:rPr>
+              <a:t>Status — Not Yet Complete</a:t>
+            </a:r>
+            <a:endParaRPr lang="en-US" sz="2800" dirty="0"/>
+          </a:p>
+        </p:txBody>
+      </p:sp>
+      <p:sp>
+        <p:nvSpPr>
+          <p:cNvPr id="3" name="Text 1"/>
+          <p:cNvSpPr txBox="1"/>
+          <p:nvPr/>
+        </p:nvSpPr>
+        <p:spPr>
+          <a:xfrm>
+            <a:off x="548640" y="1463040"/>
+            <a:ext cx="11091672" cy="4754880"/>
+          </a:xfrm>
+          <a:prstGeom prst="rect">
+            <a:avLst/>
+          </a:prstGeom>
+          <a:noFill/>
+          <a:ln/>
+        </p:spPr>
+        <p:txBody>
+          <a:bodyPr wrap="square" rtlCol="0" anchor="t"/>
+          <a:lstStyle/>
+          <a:p>
+            <a:pPr marL="228600" indent="-228600">
+              <a:spcAft>
+                <a:spcPts val="1600"/>
+              </a:spcAft>
+              <a:buSzPct val="100000"/>
+              <a:buChar char="•"/>
+            </a:pPr>
+            <a:r>
+              <a:rPr lang="en-US" sz="1900" dirty="0">
+                <a:solidFill>
+                  <a:srgbClr val="000000"/>
+                </a:solidFill>
+                <a:latin typeface="Calibri" pitchFamily="34" charset="0"/>
+                <a:ea typeface="Calibri" pitchFamily="34" charset="-122"/>
+                <a:cs typeface="Calibri" pitchFamily="34" charset="-120"/>
+              </a:rPr>
+              <a:t>Weighted-load calibration runs — the data needed to actually build the predictive model</a:t>
+            </a:r>
+            <a:endParaRPr lang="en-US" sz="1900" dirty="0"/>
+          </a:p>
+          <a:p>
+            <a:pPr marL="228600" indent="-228600">
+              <a:spcAft>
+                <a:spcPts val="1600"/>
+              </a:spcAft>
+              <a:buSzPct val="100000"/>
+              <a:buChar char="•"/>
+            </a:pPr>
+            <a:r>
+              <a:rPr lang="en-US" sz="1900" dirty="0">
+                <a:solidFill>
+                  <a:srgbClr val="000000"/>
+                </a:solidFill>
+                <a:latin typeface="Calibri" pitchFamily="34" charset="0"/>
+                <a:ea typeface="Calibri" pitchFamily="34" charset="-122"/>
+                <a:cs typeface="Calibri" pitchFamily="34" charset="-120"/>
+              </a:rPr>
+              <a:t>Keypad + HMI integration on the controller (data entry, predicted load/speed display)</a:t>
+            </a:r>
+            <a:endParaRPr lang="en-US" sz="1900" dirty="0"/>
+          </a:p>
+          <a:p>
+            <a:pPr marL="228600" indent="-228600">
+              <a:spcAft>
+                <a:spcPts val="1600"/>
+              </a:spcAft>
+              <a:buSzPct val="100000"/>
+              <a:buChar char="•"/>
+            </a:pPr>
+            <a:r>
+              <a:rPr lang="en-US" sz="1900" dirty="0">
+                <a:solidFill>
+                  <a:srgbClr val="000000"/>
+                </a:solidFill>
+                <a:latin typeface="Calibri" pitchFamily="34" charset="0"/>
+                <a:ea typeface="Calibri" pitchFamily="34" charset="-122"/>
+                <a:cs typeface="Calibri" pitchFamily="34" charset="-120"/>
+              </a:rPr>
+              <a:t>Predictive model: fit and validate slip-to-load and current-to-load estimates</a:t>
+            </a:r>
+            <a:endParaRPr lang="en-US" sz="1900" dirty="0"/>
+          </a:p>
+          <a:p>
+            <a:pPr marL="228600" indent="-228600">
+              <a:spcAft>
+                <a:spcPts val="1600"/>
+              </a:spcAft>
+              <a:buSzPct val="100000"/>
+              <a:buChar char="•"/>
+            </a:pPr>
+            <a:r>
+              <a:rPr lang="en-US" sz="1900" dirty="0">
+                <a:solidFill>
+                  <a:srgbClr val="000000"/>
+                </a:solidFill>
+                <a:latin typeface="Calibri" pitchFamily="34" charset="0"/>
+                <a:ea typeface="Calibri" pitchFamily="34" charset="-122"/>
+                <a:cs typeface="Calibri" pitchFamily="34" charset="-120"/>
+              </a:rPr>
+              <a:t>Short conference-formatted paper</a:t>
+            </a:r>
+            <a:endParaRPr lang="en-US" sz="1900" dirty="0"/>
+          </a:p>
+          <a:p>
+            <a:pPr marL="228600" indent="-228600">
+              <a:spcAft>
+                <a:spcPts val="1600"/>
+              </a:spcAft>
+              <a:buSzPct val="100000"/>
+              <a:buChar char="•"/>
+            </a:pPr>
+            <a:r>
+              <a:rPr lang="en-US" sz="1900" dirty="0">
+                <a:solidFill>
+                  <a:srgbClr val="000000"/>
+                </a:solidFill>
+                <a:latin typeface="Calibri" pitchFamily="34" charset="0"/>
+                <a:ea typeface="Calibri" pitchFamily="34" charset="-122"/>
+                <a:cs typeface="Calibri" pitchFamily="34" charset="-120"/>
+              </a:rPr>
+              <a:t>Final presentation to faculty</a:t>
+            </a:r>
+            <a:endParaRPr lang="en-US" sz="1900" dirty="0"/>
+          </a:p>
+        </p:txBody>
+      </p:sp>
+      <p:sp>
+        <p:nvSpPr>
+          <p:cNvPr id="4" name="Text 2"/>
+          <p:cNvSpPr txBox="1"/>
+          <p:nvPr/>
+        </p:nvSpPr>
+        <p:spPr>
+          <a:xfrm>
+            <a:off x="11457432" y="6446520"/>
+            <a:ext cx="457200" cy="274320"/>
+          </a:xfrm>
+          <a:prstGeom prst="rect">
+            <a:avLst/>
+          </a:prstGeom>
+          <a:noFill/>
+          <a:ln/>
+        </p:spPr>
+        <p:txBody>
+          <a:bodyPr wrap="square" rtlCol="0" anchor="ctr"/>
+          <a:lstStyle/>
+          <a:p>
+            <a:pPr algn="r" indent="0" marL="0">
+              <a:buNone/>
+            </a:pPr>
+            <a:r>
+              <a:rPr lang="en-US" sz="1000" dirty="0">
+                <a:solidFill>
+                  <a:srgbClr val="595959"/>
+                </a:solidFill>
+                <a:latin typeface="Calibri" pitchFamily="34" charset="0"/>
+                <a:ea typeface="Calibri" pitchFamily="34" charset="-122"/>
+                <a:cs typeface="Calibri" pitchFamily="34" charset="-120"/>
+              </a:rPr>
+              <a:t>6</a:t>
+            </a:r>
+            <a:endParaRPr lang="en-US" sz="1000" dirty="0"/>
+          </a:p>
+        </p:txBody>
+      </p:sp>
+    </p:spTree>
+  </p:cSld>
+  <p:clrMapOvr>
+    <a:masterClrMapping/>
+  </p:clrMapOvr>
+</p:sld>
+</file>
+
+<file path=ppt/slides/slide7.xml><?xml version="1.0" encoding="utf-8"?>
+<p:sld xmlns:a="http://schemas.openxmlformats.org/drawingml/2006/main" xmlns:r="http://schemas.openxmlformats.org/officeDocument/2006/relationships" xmlns:p="http://schemas.openxmlformats.org/presentationml/2006/main">
+  <p:cSld name="Slide 7">
+    <p:spTree>
+      <p:nvGrpSpPr>
+        <p:cNvPr id="1" name=""/>
+        <p:cNvGrpSpPr/>
+        <p:nvPr/>
+      </p:nvGrpSpPr>
+      <p:grpSpPr>
+        <a:xfrm>
+          <a:off x="0" y="0"/>
+          <a:ext cx="0" cy="0"/>
+          <a:chOff x="0" y="0"/>
+          <a:chExt cx="0" cy="0"/>
+        </a:xfrm>
+      </p:grpSpPr>
+      <p:sp>
+        <p:nvSpPr>
+          <p:cNvPr id="2" name="Text 0"/>
+          <p:cNvSpPr txBox="1"/>
+          <p:nvPr/>
+        </p:nvSpPr>
+        <p:spPr>
+          <a:xfrm>
+            <a:off x="548640" y="365760"/>
+            <a:ext cx="11091672" cy="822960"/>
+          </a:xfrm>
+          <a:prstGeom prst="rect">
+            <a:avLst/>
+          </a:prstGeom>
+          <a:noFill/>
+          <a:ln/>
+        </p:spPr>
+        <p:txBody>
+          <a:bodyPr wrap="square" rtlCol="0" anchor="t"/>
+          <a:lstStyle/>
+          <a:p>
+            <a:pPr algn="l" indent="0" marL="0">
+              <a:buNone/>
+            </a:pPr>
+            <a:r>
+              <a:rPr lang="en-US" sz="2800" b="1" dirty="0">
+                <a:solidFill>
+                  <a:srgbClr val="000000"/>
+                </a:solidFill>
+                <a:latin typeface="Calibri" pitchFamily="34" charset="0"/>
+                <a:ea typeface="Calibri" pitchFamily="34" charset="-122"/>
+                <a:cs typeface="Calibri" pitchFamily="34" charset="-120"/>
+              </a:rPr>
               <a:t>Baseline Results So Far (No Load)</a:t>
             </a:r>
             <a:endParaRPr lang="en-US" sz="2800" dirty="0"/>
@@ -2978,7 +3511,7 @@
       </p:sp>
       <p:graphicFrame>
         <p:nvGraphicFramePr>
-          <p:cNvPr id="7" name="Table 0"/>
+          <p:cNvPr id="8" name="Table 0"/>
           <p:cNvGraphicFramePr>
             <a:graphicFrameLocks noGrp="1"/>
           </p:cNvGraphicFramePr>
@@ -4543,7 +5076,7 @@
                           <a:ea typeface="Calibri" pitchFamily="34" charset="-122"/>
                           <a:cs typeface="Calibri" pitchFamily="34" charset="-120"/>
                         </a:rPr>
-                        <a:t>—</a:t>
+                        <a:t>—*</a:t>
                       </a:r>
                       <a:endParaRPr lang="en-US" sz="1300" dirty="0">
                         <a:latin typeface="Calibri" charset="0"/>
@@ -5124,8 +5657,8 @@
         </p:nvSpPr>
         <p:spPr>
           <a:xfrm>
-            <a:off x="11457432" y="6446520"/>
-            <a:ext cx="457200" cy="274320"/>
+            <a:off x="548640" y="6263640"/>
+            <a:ext cx="10360152" cy="365760"/>
           </a:xfrm>
           <a:prstGeom prst="rect">
             <a:avLst/>
@@ -5137,11 +5670,11 @@
           <a:bodyPr wrap="square" rtlCol="0" anchor="ctr"/>
           <a:lstStyle/>
           <a:p>
-            <a:pPr algn="r" indent="0" marL="0">
+            <a:pPr indent="0" marL="0">
               <a:buNone/>
             </a:pPr>
             <a:r>
-              <a:rPr lang="en-US" sz="1000" dirty="0">
+              <a:rPr lang="en-US" sz="1050" i="1" dirty="0">
                 <a:solidFill>
                   <a:srgbClr val="595959"/>
                 </a:solidFill>
@@ -5149,292 +5682,15 @@
                 <a:ea typeface="Calibri" pitchFamily="34" charset="-122"/>
                 <a:cs typeface="Calibri" pitchFamily="34" charset="-120"/>
               </a:rPr>
-              <a:t>6</a:t>
-            </a:r>
-            <a:endParaRPr lang="en-US" sz="1000" dirty="0"/>
+              <a:t>* 4.85 Hz down: only one full run was logged that session (the up run); the down RPM was noted by eye with no matching logged run, so no current reading exists for it.</a:t>
+            </a:r>
+            <a:endParaRPr lang="en-US" sz="1050" dirty="0"/>
           </a:p>
         </p:txBody>
       </p:sp>
-    </p:spTree>
-  </p:cSld>
-  <p:clrMapOvr>
-    <a:masterClrMapping/>
-  </p:clrMapOvr>
-</p:sld>
-</file>
-
-<file path=ppt/slides/slide7.xml><?xml version="1.0" encoding="utf-8"?>
-<p:sld xmlns:a="http://schemas.openxmlformats.org/drawingml/2006/main" xmlns:r="http://schemas.openxmlformats.org/officeDocument/2006/relationships" xmlns:p="http://schemas.openxmlformats.org/presentationml/2006/main">
-  <p:cSld name="Slide 7">
-    <p:spTree>
-      <p:nvGrpSpPr>
-        <p:cNvPr id="1" name=""/>
-        <p:cNvGrpSpPr/>
-        <p:nvPr/>
-      </p:nvGrpSpPr>
-      <p:grpSpPr>
-        <a:xfrm>
-          <a:off x="0" y="0"/>
-          <a:ext cx="0" cy="0"/>
-          <a:chOff x="0" y="0"/>
-          <a:chExt cx="0" cy="0"/>
-        </a:xfrm>
-      </p:grpSpPr>
-      <p:sp>
-        <p:nvSpPr>
-          <p:cNvPr id="2" name="Text 0"/>
-          <p:cNvSpPr txBox="1"/>
-          <p:nvPr/>
-        </p:nvSpPr>
-        <p:spPr>
-          <a:xfrm>
-            <a:off x="548640" y="365760"/>
-            <a:ext cx="11091672" cy="822960"/>
-          </a:xfrm>
-          <a:prstGeom prst="rect">
-            <a:avLst/>
-          </a:prstGeom>
-          <a:noFill/>
-          <a:ln/>
-        </p:spPr>
-        <p:txBody>
-          <a:bodyPr wrap="square" rtlCol="0" anchor="t"/>
-          <a:lstStyle/>
-          <a:p>
-            <a:pPr algn="l" indent="0" marL="0">
-              <a:buNone/>
-            </a:pPr>
-            <a:r>
-              <a:rPr lang="en-US" sz="2800" b="1" dirty="0">
-                <a:solidFill>
-                  <a:srgbClr val="000000"/>
-                </a:solidFill>
-                <a:latin typeface="Calibri" pitchFamily="34" charset="0"/>
-                <a:ea typeface="Calibri" pitchFamily="34" charset="-122"/>
-                <a:cs typeface="Calibri" pitchFamily="34" charset="-120"/>
-              </a:rPr>
-              <a:t>What's Left</a:t>
-            </a:r>
-            <a:endParaRPr lang="en-US" sz="2800" dirty="0"/>
-          </a:p>
-        </p:txBody>
-      </p:sp>
-      <p:sp>
-        <p:nvSpPr>
-          <p:cNvPr id="3" name="Text 1"/>
-          <p:cNvSpPr txBox="1"/>
-          <p:nvPr/>
-        </p:nvSpPr>
-        <p:spPr>
-          <a:xfrm>
-            <a:off x="548640" y="1463040"/>
-            <a:ext cx="11091672" cy="1188720"/>
-          </a:xfrm>
-          <a:prstGeom prst="rect">
-            <a:avLst/>
-          </a:prstGeom>
-          <a:noFill/>
-          <a:ln/>
-        </p:spPr>
-        <p:txBody>
-          <a:bodyPr wrap="square" rtlCol="0" anchor="t"/>
-          <a:lstStyle/>
-          <a:p>
-            <a:pPr marL="228600" indent="-228600">
-              <a:spcAft>
-                <a:spcPts val="1000"/>
-              </a:spcAft>
-              <a:buSzPct val="100000"/>
-              <a:buChar char="•"/>
-            </a:pPr>
-            <a:r>
-              <a:rPr lang="en-US" sz="1700" dirty="0">
-                <a:solidFill>
-                  <a:srgbClr val="000000"/>
-                </a:solidFill>
-                <a:latin typeface="Calibri" pitchFamily="34" charset="0"/>
-                <a:ea typeface="Calibri" pitchFamily="34" charset="-122"/>
-                <a:cs typeface="Calibri" pitchFamily="34" charset="-120"/>
-              </a:rPr>
-              <a:t>Run weighted calibration tests at 6.36 Hz (known loads, up and down, several repeats per weight) to build the slip-to-load and current-to-load models</a:t>
-            </a:r>
-            <a:endParaRPr lang="en-US" sz="1700" dirty="0"/>
-          </a:p>
-          <a:p>
-            <a:pPr marL="228600" indent="-228600">
-              <a:spcAft>
-                <a:spcPts val="1000"/>
-              </a:spcAft>
-              <a:buSzPct val="100000"/>
-              <a:buChar char="•"/>
-            </a:pPr>
-            <a:r>
-              <a:rPr lang="en-US" sz="1700" dirty="0">
-                <a:solidFill>
-                  <a:srgbClr val="000000"/>
-                </a:solidFill>
-                <a:latin typeface="Calibri" pitchFamily="34" charset="0"/>
-                <a:ea typeface="Calibri" pitchFamily="34" charset="-122"/>
-                <a:cs typeface="Calibri" pitchFamily="34" charset="-120"/>
-              </a:rPr>
-              <a:t>Add a keypad and HMI display to the controller:</a:t>
-            </a:r>
-            <a:endParaRPr lang="en-US" sz="1700" dirty="0"/>
-          </a:p>
-        </p:txBody>
-      </p:sp>
-      <p:sp>
-        <p:nvSpPr>
-          <p:cNvPr id="4" name="Text 2"/>
-          <p:cNvSpPr txBox="1"/>
-          <p:nvPr/>
-        </p:nvSpPr>
-        <p:spPr>
-          <a:xfrm>
-            <a:off x="914400" y="2514600"/>
-            <a:ext cx="10725912" cy="914400"/>
-          </a:xfrm>
-          <a:prstGeom prst="rect">
-            <a:avLst/>
-          </a:prstGeom>
-          <a:noFill/>
-          <a:ln/>
-        </p:spPr>
-        <p:txBody>
-          <a:bodyPr wrap="square" rtlCol="0" anchor="t"/>
-          <a:lstStyle/>
-          <a:p>
-            <a:pPr marL="228600" indent="-228600">
-              <a:spcAft>
-                <a:spcPts val="800"/>
-              </a:spcAft>
-              <a:buSzPct val="100000"/>
-              <a:buChar char="•"/>
-            </a:pPr>
-            <a:r>
-              <a:rPr lang="en-US" sz="1600" dirty="0">
-                <a:solidFill>
-                  <a:srgbClr val="000000"/>
-                </a:solidFill>
-                <a:latin typeface="Calibri" pitchFamily="34" charset="0"/>
-                <a:ea typeface="Calibri" pitchFamily="34" charset="-122"/>
-                <a:cs typeface="Calibri" pitchFamily="34" charset="-120"/>
-              </a:rPr>
-              <a:t>Keypad — enter test data (load, RPM) directly at the rig</a:t>
-            </a:r>
-            <a:endParaRPr lang="en-US" sz="1600" dirty="0"/>
-          </a:p>
-          <a:p>
-            <a:pPr marL="228600" indent="-228600">
-              <a:spcAft>
-                <a:spcPts val="800"/>
-              </a:spcAft>
-              <a:buSzPct val="100000"/>
-              <a:buChar char="•"/>
-            </a:pPr>
-            <a:r>
-              <a:rPr lang="en-US" sz="1600" dirty="0">
-                <a:solidFill>
-                  <a:srgbClr val="000000"/>
-                </a:solidFill>
-                <a:latin typeface="Calibri" pitchFamily="34" charset="0"/>
-                <a:ea typeface="Calibri" pitchFamily="34" charset="-122"/>
-                <a:cs typeface="Calibri" pitchFamily="34" charset="-120"/>
-              </a:rPr>
-              <a:t>HMI display — show the predicted load and speed in real time</a:t>
-            </a:r>
-            <a:endParaRPr lang="en-US" sz="1600" dirty="0"/>
-          </a:p>
-        </p:txBody>
-      </p:sp>
-      <p:sp>
-        <p:nvSpPr>
-          <p:cNvPr id="5" name="Text 3"/>
-          <p:cNvSpPr txBox="1"/>
-          <p:nvPr/>
-        </p:nvSpPr>
-        <p:spPr>
-          <a:xfrm>
-            <a:off x="548640" y="3566160"/>
-            <a:ext cx="11091672" cy="2286000"/>
-          </a:xfrm>
-          <a:prstGeom prst="rect">
-            <a:avLst/>
-          </a:prstGeom>
-          <a:noFill/>
-          <a:ln/>
-        </p:spPr>
-        <p:txBody>
-          <a:bodyPr wrap="square" rtlCol="0" anchor="t"/>
-          <a:lstStyle/>
-          <a:p>
-            <a:pPr marL="228600" indent="-228600">
-              <a:spcAft>
-                <a:spcPts val="1000"/>
-              </a:spcAft>
-              <a:buSzPct val="100000"/>
-              <a:buChar char="•"/>
-            </a:pPr>
-            <a:r>
-              <a:rPr lang="en-US" sz="1700" dirty="0">
-                <a:solidFill>
-                  <a:srgbClr val="000000"/>
-                </a:solidFill>
-                <a:latin typeface="Calibri" pitchFamily="34" charset="0"/>
-                <a:ea typeface="Calibri" pitchFamily="34" charset="-122"/>
-                <a:cs typeface="Calibri" pitchFamily="34" charset="-120"/>
-              </a:rPr>
-              <a:t>Fit and validate the predictive model against held-out data</a:t>
-            </a:r>
-            <a:endParaRPr lang="en-US" sz="1700" dirty="0"/>
-          </a:p>
-          <a:p>
-            <a:pPr marL="228600" indent="-228600">
-              <a:spcAft>
-                <a:spcPts val="1000"/>
-              </a:spcAft>
-              <a:buSzPct val="100000"/>
-              <a:buChar char="•"/>
-            </a:pPr>
-            <a:r>
-              <a:rPr lang="en-US" sz="1700" dirty="0">
-                <a:solidFill>
-                  <a:srgbClr val="000000"/>
-                </a:solidFill>
-                <a:latin typeface="Calibri" pitchFamily="34" charset="0"/>
-                <a:ea typeface="Calibri" pitchFamily="34" charset="-122"/>
-                <a:cs typeface="Calibri" pitchFamily="34" charset="-120"/>
-              </a:rPr>
-              <a:t>Write the short conference-formatted paper</a:t>
-            </a:r>
-            <a:endParaRPr lang="en-US" sz="1700" dirty="0"/>
-          </a:p>
-          <a:p>
-            <a:pPr marL="228600" indent="-228600">
-              <a:spcAft>
-                <a:spcPts val="1000"/>
-              </a:spcAft>
-              <a:buSzPct val="100000"/>
-              <a:buChar char="•"/>
-            </a:pPr>
-            <a:r>
-              <a:rPr lang="en-US" sz="1700" dirty="0">
-                <a:solidFill>
-                  <a:srgbClr val="000000"/>
-                </a:solidFill>
-                <a:latin typeface="Calibri" pitchFamily="34" charset="0"/>
-                <a:ea typeface="Calibri" pitchFamily="34" charset="-122"/>
-                <a:cs typeface="Calibri" pitchFamily="34" charset="-120"/>
-              </a:rPr>
-              <a:t>Prepare and deliver the final presentation</a:t>
-            </a:r>
-            <a:endParaRPr lang="en-US" sz="1700" dirty="0"/>
-          </a:p>
-        </p:txBody>
-      </p:sp>
-      <p:sp>
-        <p:nvSpPr>
-          <p:cNvPr id="6" name="Text 4"/>
+      <p:sp>
+        <p:nvSpPr>
+          <p:cNvPr id="9" name="Text 6"/>
           <p:cNvSpPr txBox="1"/>
           <p:nvPr/>
         </p:nvSpPr>
@@ -5504,8 +5760,8 @@
         </p:nvSpPr>
         <p:spPr>
           <a:xfrm>
-            <a:off x="548640" y="2880360"/>
-            <a:ext cx="11091672" cy="914400"/>
+            <a:off x="548640" y="365760"/>
+            <a:ext cx="11091672" cy="822960"/>
           </a:xfrm>
           <a:prstGeom prst="rect">
             <a:avLst/>
@@ -5514,14 +5770,14 @@
           <a:ln/>
         </p:spPr>
         <p:txBody>
-          <a:bodyPr wrap="square" rtlCol="0" anchor="ctr"/>
+          <a:bodyPr wrap="square" rtlCol="0" anchor="t"/>
           <a:lstStyle/>
           <a:p>
             <a:pPr algn="l" indent="0" marL="0">
               <a:buNone/>
             </a:pPr>
             <a:r>
-              <a:rPr lang="en-US" sz="3200" b="1" dirty="0">
+              <a:rPr lang="en-US" sz="2800" b="1" dirty="0">
                 <a:solidFill>
                   <a:srgbClr val="000000"/>
                 </a:solidFill>
@@ -5529,15 +5785,228 @@
                 <a:ea typeface="Calibri" pitchFamily="34" charset="-122"/>
                 <a:cs typeface="Calibri" pitchFamily="34" charset="-120"/>
               </a:rPr>
-              <a:t>Questions?</a:t>
-            </a:r>
-            <a:endParaRPr lang="en-US" sz="3200" dirty="0"/>
+              <a:t>What's Left</a:t>
+            </a:r>
+            <a:endParaRPr lang="en-US" sz="2800" dirty="0"/>
           </a:p>
         </p:txBody>
       </p:sp>
       <p:sp>
         <p:nvSpPr>
           <p:cNvPr id="3" name="Text 1"/>
+          <p:cNvSpPr txBox="1"/>
+          <p:nvPr/>
+        </p:nvSpPr>
+        <p:spPr>
+          <a:xfrm>
+            <a:off x="548640" y="1463040"/>
+            <a:ext cx="11091672" cy="1188720"/>
+          </a:xfrm>
+          <a:prstGeom prst="rect">
+            <a:avLst/>
+          </a:prstGeom>
+          <a:noFill/>
+          <a:ln/>
+        </p:spPr>
+        <p:txBody>
+          <a:bodyPr wrap="square" rtlCol="0" anchor="t"/>
+          <a:lstStyle/>
+          <a:p>
+            <a:pPr marL="228600" indent="-228600">
+              <a:spcAft>
+                <a:spcPts val="1000"/>
+              </a:spcAft>
+              <a:buSzPct val="100000"/>
+              <a:buChar char="•"/>
+            </a:pPr>
+            <a:r>
+              <a:rPr lang="en-US" sz="1700" dirty="0">
+                <a:solidFill>
+                  <a:srgbClr val="000000"/>
+                </a:solidFill>
+                <a:latin typeface="Calibri" pitchFamily="34" charset="0"/>
+                <a:ea typeface="Calibri" pitchFamily="34" charset="-122"/>
+                <a:cs typeface="Calibri" pitchFamily="34" charset="-120"/>
+              </a:rPr>
+              <a:t>Run weighted calibration tests at 6.36 Hz (known loads, up and down, several repeats per weight) to build the slip-to-load and current-to-load models</a:t>
+            </a:r>
+            <a:endParaRPr lang="en-US" sz="1700" dirty="0"/>
+          </a:p>
+          <a:p>
+            <a:pPr marL="228600" indent="-228600">
+              <a:spcAft>
+                <a:spcPts val="1000"/>
+              </a:spcAft>
+              <a:buSzPct val="100000"/>
+              <a:buChar char="•"/>
+            </a:pPr>
+            <a:r>
+              <a:rPr lang="en-US" sz="1700" dirty="0">
+                <a:solidFill>
+                  <a:srgbClr val="000000"/>
+                </a:solidFill>
+                <a:latin typeface="Calibri" pitchFamily="34" charset="0"/>
+                <a:ea typeface="Calibri" pitchFamily="34" charset="-122"/>
+                <a:cs typeface="Calibri" pitchFamily="34" charset="-120"/>
+              </a:rPr>
+              <a:t>Add a keypad and HMI display to the controller:</a:t>
+            </a:r>
+            <a:endParaRPr lang="en-US" sz="1700" dirty="0"/>
+          </a:p>
+        </p:txBody>
+      </p:sp>
+      <p:sp>
+        <p:nvSpPr>
+          <p:cNvPr id="4" name="Text 2"/>
+          <p:cNvSpPr txBox="1"/>
+          <p:nvPr/>
+        </p:nvSpPr>
+        <p:spPr>
+          <a:xfrm>
+            <a:off x="914400" y="2514600"/>
+            <a:ext cx="10725912" cy="914400"/>
+          </a:xfrm>
+          <a:prstGeom prst="rect">
+            <a:avLst/>
+          </a:prstGeom>
+          <a:noFill/>
+          <a:ln/>
+        </p:spPr>
+        <p:txBody>
+          <a:bodyPr wrap="square" rtlCol="0" anchor="t"/>
+          <a:lstStyle/>
+          <a:p>
+            <a:pPr marL="228600" indent="-228600">
+              <a:spcAft>
+                <a:spcPts val="800"/>
+              </a:spcAft>
+              <a:buSzPct val="100000"/>
+              <a:buChar char="•"/>
+            </a:pPr>
+            <a:r>
+              <a:rPr lang="en-US" sz="1600" dirty="0">
+                <a:solidFill>
+                  <a:srgbClr val="000000"/>
+                </a:solidFill>
+                <a:latin typeface="Calibri" pitchFamily="34" charset="0"/>
+                <a:ea typeface="Calibri" pitchFamily="34" charset="-122"/>
+                <a:cs typeface="Calibri" pitchFamily="34" charset="-120"/>
+              </a:rPr>
+              <a:t>Keypad — enter test data (load, RPM) directly at the rig</a:t>
+            </a:r>
+            <a:endParaRPr lang="en-US" sz="1600" dirty="0"/>
+          </a:p>
+          <a:p>
+            <a:pPr marL="228600" indent="-228600">
+              <a:spcAft>
+                <a:spcPts val="800"/>
+              </a:spcAft>
+              <a:buSzPct val="100000"/>
+              <a:buChar char="•"/>
+            </a:pPr>
+            <a:r>
+              <a:rPr lang="en-US" sz="1600" dirty="0">
+                <a:solidFill>
+                  <a:srgbClr val="000000"/>
+                </a:solidFill>
+                <a:latin typeface="Calibri" pitchFamily="34" charset="0"/>
+                <a:ea typeface="Calibri" pitchFamily="34" charset="-122"/>
+                <a:cs typeface="Calibri" pitchFamily="34" charset="-120"/>
+              </a:rPr>
+              <a:t>HMI display — show the predicted load and speed in real time</a:t>
+            </a:r>
+            <a:endParaRPr lang="en-US" sz="1600" dirty="0"/>
+          </a:p>
+        </p:txBody>
+      </p:sp>
+      <p:sp>
+        <p:nvSpPr>
+          <p:cNvPr id="5" name="Text 3"/>
+          <p:cNvSpPr txBox="1"/>
+          <p:nvPr/>
+        </p:nvSpPr>
+        <p:spPr>
+          <a:xfrm>
+            <a:off x="548640" y="3566160"/>
+            <a:ext cx="11091672" cy="2286000"/>
+          </a:xfrm>
+          <a:prstGeom prst="rect">
+            <a:avLst/>
+          </a:prstGeom>
+          <a:noFill/>
+          <a:ln/>
+        </p:spPr>
+        <p:txBody>
+          <a:bodyPr wrap="square" rtlCol="0" anchor="t"/>
+          <a:lstStyle/>
+          <a:p>
+            <a:pPr marL="228600" indent="-228600">
+              <a:spcAft>
+                <a:spcPts val="1000"/>
+              </a:spcAft>
+              <a:buSzPct val="100000"/>
+              <a:buChar char="•"/>
+            </a:pPr>
+            <a:r>
+              <a:rPr lang="en-US" sz="1700" dirty="0">
+                <a:solidFill>
+                  <a:srgbClr val="000000"/>
+                </a:solidFill>
+                <a:latin typeface="Calibri" pitchFamily="34" charset="0"/>
+                <a:ea typeface="Calibri" pitchFamily="34" charset="-122"/>
+                <a:cs typeface="Calibri" pitchFamily="34" charset="-120"/>
+              </a:rPr>
+              <a:t>Fit and validate the predictive model against held-out data</a:t>
+            </a:r>
+            <a:endParaRPr lang="en-US" sz="1700" dirty="0"/>
+          </a:p>
+          <a:p>
+            <a:pPr marL="228600" indent="-228600">
+              <a:spcAft>
+                <a:spcPts val="1000"/>
+              </a:spcAft>
+              <a:buSzPct val="100000"/>
+              <a:buChar char="•"/>
+            </a:pPr>
+            <a:r>
+              <a:rPr lang="en-US" sz="1700" dirty="0">
+                <a:solidFill>
+                  <a:srgbClr val="000000"/>
+                </a:solidFill>
+                <a:latin typeface="Calibri" pitchFamily="34" charset="0"/>
+                <a:ea typeface="Calibri" pitchFamily="34" charset="-122"/>
+                <a:cs typeface="Calibri" pitchFamily="34" charset="-120"/>
+              </a:rPr>
+              <a:t>Write the short conference-formatted paper</a:t>
+            </a:r>
+            <a:endParaRPr lang="en-US" sz="1700" dirty="0"/>
+          </a:p>
+          <a:p>
+            <a:pPr marL="228600" indent="-228600">
+              <a:spcAft>
+                <a:spcPts val="1000"/>
+              </a:spcAft>
+              <a:buSzPct val="100000"/>
+              <a:buChar char="•"/>
+            </a:pPr>
+            <a:r>
+              <a:rPr lang="en-US" sz="1700" dirty="0">
+                <a:solidFill>
+                  <a:srgbClr val="000000"/>
+                </a:solidFill>
+                <a:latin typeface="Calibri" pitchFamily="34" charset="0"/>
+                <a:ea typeface="Calibri" pitchFamily="34" charset="-122"/>
+                <a:cs typeface="Calibri" pitchFamily="34" charset="-120"/>
+              </a:rPr>
+              <a:t>Prepare and deliver the final presentation</a:t>
+            </a:r>
+            <a:endParaRPr lang="en-US" sz="1700" dirty="0"/>
+          </a:p>
+        </p:txBody>
+      </p:sp>
+      <p:sp>
+        <p:nvSpPr>
+          <p:cNvPr id="6" name="Text 4"/>
           <p:cNvSpPr txBox="1"/>
           <p:nvPr/>
         </p:nvSpPr>
@@ -5569,6 +6038,1108 @@
                 <a:cs typeface="Calibri" pitchFamily="34" charset="-120"/>
               </a:rPr>
               <a:t>8</a:t>
+            </a:r>
+            <a:endParaRPr lang="en-US" sz="1000" dirty="0"/>
+          </a:p>
+        </p:txBody>
+      </p:sp>
+    </p:spTree>
+  </p:cSld>
+  <p:clrMapOvr>
+    <a:masterClrMapping/>
+  </p:clrMapOvr>
+</p:sld>
+</file>
+
+<file path=ppt/slides/slide9.xml><?xml version="1.0" encoding="utf-8"?>
+<p:sld xmlns:a="http://schemas.openxmlformats.org/drawingml/2006/main" xmlns:r="http://schemas.openxmlformats.org/officeDocument/2006/relationships" xmlns:p="http://schemas.openxmlformats.org/presentationml/2006/main">
+  <p:cSld name="Slide 9">
+    <p:spTree>
+      <p:nvGrpSpPr>
+        <p:cNvPr id="1" name=""/>
+        <p:cNvGrpSpPr/>
+        <p:nvPr/>
+      </p:nvGrpSpPr>
+      <p:grpSpPr>
+        <a:xfrm>
+          <a:off x="0" y="0"/>
+          <a:ext cx="0" cy="0"/>
+          <a:chOff x="0" y="0"/>
+          <a:chExt cx="0" cy="0"/>
+        </a:xfrm>
+      </p:grpSpPr>
+      <p:sp>
+        <p:nvSpPr>
+          <p:cNvPr id="2" name="Text 0"/>
+          <p:cNvSpPr txBox="1"/>
+          <p:nvPr/>
+        </p:nvSpPr>
+        <p:spPr>
+          <a:xfrm>
+            <a:off x="548640" y="365760"/>
+            <a:ext cx="11091672" cy="822960"/>
+          </a:xfrm>
+          <a:prstGeom prst="rect">
+            <a:avLst/>
+          </a:prstGeom>
+          <a:noFill/>
+          <a:ln/>
+        </p:spPr>
+        <p:txBody>
+          <a:bodyPr wrap="square" rtlCol="0" anchor="t"/>
+          <a:lstStyle/>
+          <a:p>
+            <a:pPr algn="l" indent="0" marL="0">
+              <a:buNone/>
+            </a:pPr>
+            <a:r>
+              <a:rPr lang="en-US" sz="2800" b="1" dirty="0">
+                <a:solidFill>
+                  <a:srgbClr val="000000"/>
+                </a:solidFill>
+                <a:latin typeface="Calibri" pitchFamily="34" charset="0"/>
+                <a:ea typeface="Calibri" pitchFamily="34" charset="-122"/>
+                <a:cs typeface="Calibri" pitchFamily="34" charset="-120"/>
+              </a:rPr>
+              <a:t>Timeline</a:t>
+            </a:r>
+            <a:endParaRPr lang="en-US" sz="2800" dirty="0"/>
+          </a:p>
+        </p:txBody>
+      </p:sp>
+      <p:sp>
+        <p:nvSpPr>
+          <p:cNvPr id="3" name="Text 1"/>
+          <p:cNvSpPr txBox="1"/>
+          <p:nvPr/>
+        </p:nvSpPr>
+        <p:spPr>
+          <a:xfrm>
+            <a:off x="548640" y="1234440"/>
+            <a:ext cx="11091672" cy="320040"/>
+          </a:xfrm>
+          <a:prstGeom prst="rect">
+            <a:avLst/>
+          </a:prstGeom>
+          <a:noFill/>
+          <a:ln/>
+        </p:spPr>
+        <p:txBody>
+          <a:bodyPr wrap="square" rtlCol="0" anchor="ctr"/>
+          <a:lstStyle/>
+          <a:p>
+            <a:pPr indent="0" marL="0">
+              <a:buNone/>
+            </a:pPr>
+            <a:r>
+              <a:rPr lang="en-US" sz="1300" i="1" dirty="0">
+                <a:solidFill>
+                  <a:srgbClr val="595959"/>
+                </a:solidFill>
+                <a:latin typeface="Calibri" pitchFamily="34" charset="0"/>
+                <a:ea typeface="Calibri" pitchFamily="34" charset="-122"/>
+                <a:cs typeface="Calibri" pitchFamily="34" charset="-120"/>
+              </a:rPr>
+              <a:t>Last day of classes: December 2</a:t>
+            </a:r>
+            <a:endParaRPr lang="en-US" sz="1300" dirty="0"/>
+          </a:p>
+        </p:txBody>
+      </p:sp>
+      <p:graphicFrame>
+        <p:nvGraphicFramePr>
+          <p:cNvPr id="10" name="Table 0"/>
+          <p:cNvGraphicFramePr>
+            <a:graphicFrameLocks noGrp="1"/>
+          </p:cNvGraphicFramePr>
+          <p:nvPr>
+            <p:extLst>
+              <p:ext uri="{D42A27DB-BD31-4B8C-83A1-F6EECF244321}">
+                <p14:modId xmlns:p14="http://schemas.microsoft.com/office/powerpoint/2010/main" val="1579011935"/>
+              </p:ext>
+            </p:extLst>
+          </p:nvPr>
+        </p:nvGraphicFramePr>
+        <p:xfrm>
+          <a:off x="548640" y="1691640"/>
+          <a:ext cx="11091672" cy="914400"/>
+        </p:xfrm>
+        <a:graphic>
+          <a:graphicData uri="http://schemas.openxmlformats.org/drawingml/2006/table">
+            <a:tbl>
+              <a:tblPr/>
+              <a:tblGrid>
+                <a:gridCol w="2377440"/>
+                <a:gridCol w="8714232"/>
+              </a:tblGrid>
+              <a:tr h="548640">
+                <a:tc>
+                  <a:txBody>
+                    <a:bodyPr/>
+                    <a:lstStyle/>
+                    <a:p>
+                      <a:pPr indent="0" marL="0">
+                        <a:buNone/>
+                      </a:pPr>
+                      <a:r>
+                        <a:rPr lang="en-US" sz="1500" b="1" dirty="0">
+                          <a:solidFill>
+                            <a:srgbClr val="000000"/>
+                          </a:solidFill>
+                          <a:latin typeface="Calibri" pitchFamily="34" charset="0"/>
+                          <a:ea typeface="Calibri" pitchFamily="34" charset="-122"/>
+                          <a:cs typeface="Calibri" pitchFamily="34" charset="-120"/>
+                        </a:rPr>
+                        <a:t>Dates</a:t>
+                      </a:r>
+                      <a:endParaRPr lang="en-US" sz="1500" dirty="0">
+                        <a:latin typeface="Calibri" charset="0"/>
+                        <a:ea typeface="Calibri" charset="0"/>
+                        <a:cs typeface="Calibri" charset="0"/>
+                      </a:endParaRPr>
+                    </a:p>
+                  </a:txBody>
+                  <a:tcPr marL="91440" marR="91440" marT="45720" marB="45720" anchor="ctr">
+                    <a:lnL w="9525" cap="flat" cmpd="sng" algn="ctr">
+                      <a:solidFill>
+                        <a:srgbClr val="D9D9D9"/>
+                      </a:solidFill>
+                      <a:prstDash val="solid"/>
+                      <a:round/>
+                      <a:headEnd type="none" w="med" len="med"/>
+                      <a:tailEnd type="none" w="med" len="med"/>
+                    </a:lnL>
+                    <a:lnR w="9525" cap="flat" cmpd="sng" algn="ctr">
+                      <a:solidFill>
+                        <a:srgbClr val="D9D9D9"/>
+                      </a:solidFill>
+                      <a:prstDash val="solid"/>
+                      <a:round/>
+                      <a:headEnd type="none" w="med" len="med"/>
+                      <a:tailEnd type="none" w="med" len="med"/>
+                    </a:lnR>
+                    <a:lnT w="9525" cap="flat" cmpd="sng" algn="ctr">
+                      <a:solidFill>
+                        <a:srgbClr val="D9D9D9"/>
+                      </a:solidFill>
+                      <a:prstDash val="solid"/>
+                      <a:round/>
+                      <a:headEnd type="none" w="med" len="med"/>
+                      <a:tailEnd type="none" w="med" len="med"/>
+                    </a:lnT>
+                    <a:lnB w="9525" cap="flat" cmpd="sng" algn="ctr">
+                      <a:solidFill>
+                        <a:srgbClr val="D9D9D9"/>
+                      </a:solidFill>
+                      <a:prstDash val="solid"/>
+                      <a:round/>
+                      <a:headEnd type="none" w="med" len="med"/>
+                      <a:tailEnd type="none" w="med" len="med"/>
+                    </a:lnB>
+                    <a:solidFill>
+                      <a:srgbClr val="D9D9D9"/>
+                    </a:solidFill>
+                  </a:tcPr>
+                </a:tc>
+                <a:tc>
+                  <a:txBody>
+                    <a:bodyPr/>
+                    <a:lstStyle/>
+                    <a:p>
+                      <a:pPr indent="0" marL="0">
+                        <a:buNone/>
+                      </a:pPr>
+                      <a:r>
+                        <a:rPr lang="en-US" sz="1500" b="1" dirty="0">
+                          <a:solidFill>
+                            <a:srgbClr val="000000"/>
+                          </a:solidFill>
+                          <a:latin typeface="Calibri" pitchFamily="34" charset="0"/>
+                          <a:ea typeface="Calibri" pitchFamily="34" charset="-122"/>
+                          <a:cs typeface="Calibri" pitchFamily="34" charset="-120"/>
+                        </a:rPr>
+                        <a:t>Milestone</a:t>
+                      </a:r>
+                      <a:endParaRPr lang="en-US" sz="1500" dirty="0">
+                        <a:latin typeface="Calibri" charset="0"/>
+                        <a:ea typeface="Calibri" charset="0"/>
+                        <a:cs typeface="Calibri" charset="0"/>
+                      </a:endParaRPr>
+                    </a:p>
+                  </a:txBody>
+                  <a:tcPr marL="91440" marR="91440" marT="45720" marB="45720" anchor="ctr">
+                    <a:lnL w="9525" cap="flat" cmpd="sng" algn="ctr">
+                      <a:solidFill>
+                        <a:srgbClr val="D9D9D9"/>
+                      </a:solidFill>
+                      <a:prstDash val="solid"/>
+                      <a:round/>
+                      <a:headEnd type="none" w="med" len="med"/>
+                      <a:tailEnd type="none" w="med" len="med"/>
+                    </a:lnL>
+                    <a:lnR w="9525" cap="flat" cmpd="sng" algn="ctr">
+                      <a:solidFill>
+                        <a:srgbClr val="D9D9D9"/>
+                      </a:solidFill>
+                      <a:prstDash val="solid"/>
+                      <a:round/>
+                      <a:headEnd type="none" w="med" len="med"/>
+                      <a:tailEnd type="none" w="med" len="med"/>
+                    </a:lnR>
+                    <a:lnT w="9525" cap="flat" cmpd="sng" algn="ctr">
+                      <a:solidFill>
+                        <a:srgbClr val="D9D9D9"/>
+                      </a:solidFill>
+                      <a:prstDash val="solid"/>
+                      <a:round/>
+                      <a:headEnd type="none" w="med" len="med"/>
+                      <a:tailEnd type="none" w="med" len="med"/>
+                    </a:lnT>
+                    <a:lnB w="9525" cap="flat" cmpd="sng" algn="ctr">
+                      <a:solidFill>
+                        <a:srgbClr val="D9D9D9"/>
+                      </a:solidFill>
+                      <a:prstDash val="solid"/>
+                      <a:round/>
+                      <a:headEnd type="none" w="med" len="med"/>
+                      <a:tailEnd type="none" w="med" len="med"/>
+                    </a:lnB>
+                    <a:solidFill>
+                      <a:srgbClr val="D9D9D9"/>
+                    </a:solidFill>
+                  </a:tcPr>
+                </a:tc>
+              </a:tr>
+              <a:tr h="548640">
+                <a:tc>
+                  <a:txBody>
+                    <a:bodyPr/>
+                    <a:lstStyle/>
+                    <a:p>
+                      <a:pPr indent="0" marL="0">
+                        <a:buNone/>
+                      </a:pPr>
+                      <a:r>
+                        <a:rPr lang="en-US" sz="1500" dirty="0">
+                          <a:solidFill>
+                            <a:srgbClr val="000000"/>
+                          </a:solidFill>
+                          <a:latin typeface="Calibri" pitchFamily="34" charset="0"/>
+                          <a:ea typeface="Calibri" pitchFamily="34" charset="-122"/>
+                          <a:cs typeface="Calibri" pitchFamily="34" charset="-120"/>
+                        </a:rPr>
+                        <a:t>Oct 7 – Oct 17</a:t>
+                      </a:r>
+                      <a:endParaRPr lang="en-US" sz="1500" dirty="0">
+                        <a:latin typeface="Calibri" charset="0"/>
+                        <a:ea typeface="Calibri" charset="0"/>
+                        <a:cs typeface="Calibri" charset="0"/>
+                      </a:endParaRPr>
+                    </a:p>
+                  </a:txBody>
+                  <a:tcPr marL="91440" marR="91440" marT="45720" marB="45720" anchor="ctr">
+                    <a:lnL w="9525" cap="flat" cmpd="sng" algn="ctr">
+                      <a:solidFill>
+                        <a:srgbClr val="D9D9D9"/>
+                      </a:solidFill>
+                      <a:prstDash val="solid"/>
+                      <a:round/>
+                      <a:headEnd type="none" w="med" len="med"/>
+                      <a:tailEnd type="none" w="med" len="med"/>
+                    </a:lnL>
+                    <a:lnR w="9525" cap="flat" cmpd="sng" algn="ctr">
+                      <a:solidFill>
+                        <a:srgbClr val="D9D9D9"/>
+                      </a:solidFill>
+                      <a:prstDash val="solid"/>
+                      <a:round/>
+                      <a:headEnd type="none" w="med" len="med"/>
+                      <a:tailEnd type="none" w="med" len="med"/>
+                    </a:lnR>
+                    <a:lnT w="9525" cap="flat" cmpd="sng" algn="ctr">
+                      <a:solidFill>
+                        <a:srgbClr val="D9D9D9"/>
+                      </a:solidFill>
+                      <a:prstDash val="solid"/>
+                      <a:round/>
+                      <a:headEnd type="none" w="med" len="med"/>
+                      <a:tailEnd type="none" w="med" len="med"/>
+                    </a:lnT>
+                    <a:lnB w="9525" cap="flat" cmpd="sng" algn="ctr">
+                      <a:solidFill>
+                        <a:srgbClr val="D9D9D9"/>
+                      </a:solidFill>
+                      <a:prstDash val="solid"/>
+                      <a:round/>
+                      <a:headEnd type="none" w="med" len="med"/>
+                      <a:tailEnd type="none" w="med" len="med"/>
+                    </a:lnB>
+                  </a:tcPr>
+                </a:tc>
+                <a:tc>
+                  <a:txBody>
+                    <a:bodyPr/>
+                    <a:lstStyle/>
+                    <a:p>
+                      <a:pPr indent="0" marL="0">
+                        <a:buNone/>
+                      </a:pPr>
+                      <a:r>
+                        <a:rPr lang="en-US" sz="1500" dirty="0">
+                          <a:solidFill>
+                            <a:srgbClr val="000000"/>
+                          </a:solidFill>
+                          <a:latin typeface="Calibri" pitchFamily="34" charset="0"/>
+                          <a:ea typeface="Calibri" pitchFamily="34" charset="-122"/>
+                          <a:cs typeface="Calibri" pitchFamily="34" charset="-120"/>
+                        </a:rPr>
+                        <a:t>Weighted-load calibration tests at 6.36 Hz (known loads, up/down, repeats)</a:t>
+                      </a:r>
+                      <a:endParaRPr lang="en-US" sz="1500" dirty="0">
+                        <a:latin typeface="Calibri" charset="0"/>
+                        <a:ea typeface="Calibri" charset="0"/>
+                        <a:cs typeface="Calibri" charset="0"/>
+                      </a:endParaRPr>
+                    </a:p>
+                  </a:txBody>
+                  <a:tcPr marL="91440" marR="91440" marT="45720" marB="45720" anchor="ctr">
+                    <a:lnL w="9525" cap="flat" cmpd="sng" algn="ctr">
+                      <a:solidFill>
+                        <a:srgbClr val="D9D9D9"/>
+                      </a:solidFill>
+                      <a:prstDash val="solid"/>
+                      <a:round/>
+                      <a:headEnd type="none" w="med" len="med"/>
+                      <a:tailEnd type="none" w="med" len="med"/>
+                    </a:lnL>
+                    <a:lnR w="9525" cap="flat" cmpd="sng" algn="ctr">
+                      <a:solidFill>
+                        <a:srgbClr val="D9D9D9"/>
+                      </a:solidFill>
+                      <a:prstDash val="solid"/>
+                      <a:round/>
+                      <a:headEnd type="none" w="med" len="med"/>
+                      <a:tailEnd type="none" w="med" len="med"/>
+                    </a:lnR>
+                    <a:lnT w="9525" cap="flat" cmpd="sng" algn="ctr">
+                      <a:solidFill>
+                        <a:srgbClr val="D9D9D9"/>
+                      </a:solidFill>
+                      <a:prstDash val="solid"/>
+                      <a:round/>
+                      <a:headEnd type="none" w="med" len="med"/>
+                      <a:tailEnd type="none" w="med" len="med"/>
+                    </a:lnT>
+                    <a:lnB w="9525" cap="flat" cmpd="sng" algn="ctr">
+                      <a:solidFill>
+                        <a:srgbClr val="D9D9D9"/>
+                      </a:solidFill>
+                      <a:prstDash val="solid"/>
+                      <a:round/>
+                      <a:headEnd type="none" w="med" len="med"/>
+                      <a:tailEnd type="none" w="med" len="med"/>
+                    </a:lnB>
+                  </a:tcPr>
+                </a:tc>
+              </a:tr>
+              <a:tr h="548640">
+                <a:tc>
+                  <a:txBody>
+                    <a:bodyPr/>
+                    <a:lstStyle/>
+                    <a:p>
+                      <a:pPr indent="0" marL="0">
+                        <a:buNone/>
+                      </a:pPr>
+                      <a:r>
+                        <a:rPr lang="en-US" sz="1500" dirty="0">
+                          <a:solidFill>
+                            <a:srgbClr val="000000"/>
+                          </a:solidFill>
+                          <a:latin typeface="Calibri" pitchFamily="34" charset="0"/>
+                          <a:ea typeface="Calibri" pitchFamily="34" charset="-122"/>
+                          <a:cs typeface="Calibri" pitchFamily="34" charset="-120"/>
+                        </a:rPr>
+                        <a:t>Oct 17 – Oct 31</a:t>
+                      </a:r>
+                      <a:endParaRPr lang="en-US" sz="1500" dirty="0">
+                        <a:latin typeface="Calibri" charset="0"/>
+                        <a:ea typeface="Calibri" charset="0"/>
+                        <a:cs typeface="Calibri" charset="0"/>
+                      </a:endParaRPr>
+                    </a:p>
+                  </a:txBody>
+                  <a:tcPr marL="91440" marR="91440" marT="45720" marB="45720" anchor="ctr">
+                    <a:lnL w="9525" cap="flat" cmpd="sng" algn="ctr">
+                      <a:solidFill>
+                        <a:srgbClr val="D9D9D9"/>
+                      </a:solidFill>
+                      <a:prstDash val="solid"/>
+                      <a:round/>
+                      <a:headEnd type="none" w="med" len="med"/>
+                      <a:tailEnd type="none" w="med" len="med"/>
+                    </a:lnL>
+                    <a:lnR w="9525" cap="flat" cmpd="sng" algn="ctr">
+                      <a:solidFill>
+                        <a:srgbClr val="D9D9D9"/>
+                      </a:solidFill>
+                      <a:prstDash val="solid"/>
+                      <a:round/>
+                      <a:headEnd type="none" w="med" len="med"/>
+                      <a:tailEnd type="none" w="med" len="med"/>
+                    </a:lnR>
+                    <a:lnT w="9525" cap="flat" cmpd="sng" algn="ctr">
+                      <a:solidFill>
+                        <a:srgbClr val="D9D9D9"/>
+                      </a:solidFill>
+                      <a:prstDash val="solid"/>
+                      <a:round/>
+                      <a:headEnd type="none" w="med" len="med"/>
+                      <a:tailEnd type="none" w="med" len="med"/>
+                    </a:lnT>
+                    <a:lnB w="9525" cap="flat" cmpd="sng" algn="ctr">
+                      <a:solidFill>
+                        <a:srgbClr val="D9D9D9"/>
+                      </a:solidFill>
+                      <a:prstDash val="solid"/>
+                      <a:round/>
+                      <a:headEnd type="none" w="med" len="med"/>
+                      <a:tailEnd type="none" w="med" len="med"/>
+                    </a:lnB>
+                  </a:tcPr>
+                </a:tc>
+                <a:tc>
+                  <a:txBody>
+                    <a:bodyPr/>
+                    <a:lstStyle/>
+                    <a:p>
+                      <a:pPr indent="0" marL="0">
+                        <a:buNone/>
+                      </a:pPr>
+                      <a:r>
+                        <a:rPr lang="en-US" sz="1500" dirty="0">
+                          <a:solidFill>
+                            <a:srgbClr val="000000"/>
+                          </a:solidFill>
+                          <a:latin typeface="Calibri" pitchFamily="34" charset="0"/>
+                          <a:ea typeface="Calibri" pitchFamily="34" charset="-122"/>
+                          <a:cs typeface="Calibri" pitchFamily="34" charset="-120"/>
+                        </a:rPr>
+                        <a:t>Keypad + HMI integration (data entry, predicted load/speed display)</a:t>
+                      </a:r>
+                      <a:endParaRPr lang="en-US" sz="1500" dirty="0">
+                        <a:latin typeface="Calibri" charset="0"/>
+                        <a:ea typeface="Calibri" charset="0"/>
+                        <a:cs typeface="Calibri" charset="0"/>
+                      </a:endParaRPr>
+                    </a:p>
+                  </a:txBody>
+                  <a:tcPr marL="91440" marR="91440" marT="45720" marB="45720" anchor="ctr">
+                    <a:lnL w="9525" cap="flat" cmpd="sng" algn="ctr">
+                      <a:solidFill>
+                        <a:srgbClr val="D9D9D9"/>
+                      </a:solidFill>
+                      <a:prstDash val="solid"/>
+                      <a:round/>
+                      <a:headEnd type="none" w="med" len="med"/>
+                      <a:tailEnd type="none" w="med" len="med"/>
+                    </a:lnL>
+                    <a:lnR w="9525" cap="flat" cmpd="sng" algn="ctr">
+                      <a:solidFill>
+                        <a:srgbClr val="D9D9D9"/>
+                      </a:solidFill>
+                      <a:prstDash val="solid"/>
+                      <a:round/>
+                      <a:headEnd type="none" w="med" len="med"/>
+                      <a:tailEnd type="none" w="med" len="med"/>
+                    </a:lnR>
+                    <a:lnT w="9525" cap="flat" cmpd="sng" algn="ctr">
+                      <a:solidFill>
+                        <a:srgbClr val="D9D9D9"/>
+                      </a:solidFill>
+                      <a:prstDash val="solid"/>
+                      <a:round/>
+                      <a:headEnd type="none" w="med" len="med"/>
+                      <a:tailEnd type="none" w="med" len="med"/>
+                    </a:lnT>
+                    <a:lnB w="9525" cap="flat" cmpd="sng" algn="ctr">
+                      <a:solidFill>
+                        <a:srgbClr val="D9D9D9"/>
+                      </a:solidFill>
+                      <a:prstDash val="solid"/>
+                      <a:round/>
+                      <a:headEnd type="none" w="med" len="med"/>
+                      <a:tailEnd type="none" w="med" len="med"/>
+                    </a:lnB>
+                  </a:tcPr>
+                </a:tc>
+              </a:tr>
+              <a:tr h="548640">
+                <a:tc>
+                  <a:txBody>
+                    <a:bodyPr/>
+                    <a:lstStyle/>
+                    <a:p>
+                      <a:pPr indent="0" marL="0">
+                        <a:buNone/>
+                      </a:pPr>
+                      <a:r>
+                        <a:rPr lang="en-US" sz="1500" dirty="0">
+                          <a:solidFill>
+                            <a:srgbClr val="000000"/>
+                          </a:solidFill>
+                          <a:latin typeface="Calibri" pitchFamily="34" charset="0"/>
+                          <a:ea typeface="Calibri" pitchFamily="34" charset="-122"/>
+                          <a:cs typeface="Calibri" pitchFamily="34" charset="-120"/>
+                        </a:rPr>
+                        <a:t>Oct 31 – Nov 14</a:t>
+                      </a:r>
+                      <a:endParaRPr lang="en-US" sz="1500" dirty="0">
+                        <a:latin typeface="Calibri" charset="0"/>
+                        <a:ea typeface="Calibri" charset="0"/>
+                        <a:cs typeface="Calibri" charset="0"/>
+                      </a:endParaRPr>
+                    </a:p>
+                  </a:txBody>
+                  <a:tcPr marL="91440" marR="91440" marT="45720" marB="45720" anchor="ctr">
+                    <a:lnL w="9525" cap="flat" cmpd="sng" algn="ctr">
+                      <a:solidFill>
+                        <a:srgbClr val="D9D9D9"/>
+                      </a:solidFill>
+                      <a:prstDash val="solid"/>
+                      <a:round/>
+                      <a:headEnd type="none" w="med" len="med"/>
+                      <a:tailEnd type="none" w="med" len="med"/>
+                    </a:lnL>
+                    <a:lnR w="9525" cap="flat" cmpd="sng" algn="ctr">
+                      <a:solidFill>
+                        <a:srgbClr val="D9D9D9"/>
+                      </a:solidFill>
+                      <a:prstDash val="solid"/>
+                      <a:round/>
+                      <a:headEnd type="none" w="med" len="med"/>
+                      <a:tailEnd type="none" w="med" len="med"/>
+                    </a:lnR>
+                    <a:lnT w="9525" cap="flat" cmpd="sng" algn="ctr">
+                      <a:solidFill>
+                        <a:srgbClr val="D9D9D9"/>
+                      </a:solidFill>
+                      <a:prstDash val="solid"/>
+                      <a:round/>
+                      <a:headEnd type="none" w="med" len="med"/>
+                      <a:tailEnd type="none" w="med" len="med"/>
+                    </a:lnT>
+                    <a:lnB w="9525" cap="flat" cmpd="sng" algn="ctr">
+                      <a:solidFill>
+                        <a:srgbClr val="D9D9D9"/>
+                      </a:solidFill>
+                      <a:prstDash val="solid"/>
+                      <a:round/>
+                      <a:headEnd type="none" w="med" len="med"/>
+                      <a:tailEnd type="none" w="med" len="med"/>
+                    </a:lnB>
+                  </a:tcPr>
+                </a:tc>
+                <a:tc>
+                  <a:txBody>
+                    <a:bodyPr/>
+                    <a:lstStyle/>
+                    <a:p>
+                      <a:pPr indent="0" marL="0">
+                        <a:buNone/>
+                      </a:pPr>
+                      <a:r>
+                        <a:rPr lang="en-US" sz="1500" dirty="0">
+                          <a:solidFill>
+                            <a:srgbClr val="000000"/>
+                          </a:solidFill>
+                          <a:latin typeface="Calibri" pitchFamily="34" charset="0"/>
+                          <a:ea typeface="Calibri" pitchFamily="34" charset="-122"/>
+                          <a:cs typeface="Calibri" pitchFamily="34" charset="-120"/>
+                        </a:rPr>
+                        <a:t>Fit and validate the predictive model (slip-to-load, current-to-load)</a:t>
+                      </a:r>
+                      <a:endParaRPr lang="en-US" sz="1500" dirty="0">
+                        <a:latin typeface="Calibri" charset="0"/>
+                        <a:ea typeface="Calibri" charset="0"/>
+                        <a:cs typeface="Calibri" charset="0"/>
+                      </a:endParaRPr>
+                    </a:p>
+                  </a:txBody>
+                  <a:tcPr marL="91440" marR="91440" marT="45720" marB="45720" anchor="ctr">
+                    <a:lnL w="9525" cap="flat" cmpd="sng" algn="ctr">
+                      <a:solidFill>
+                        <a:srgbClr val="D9D9D9"/>
+                      </a:solidFill>
+                      <a:prstDash val="solid"/>
+                      <a:round/>
+                      <a:headEnd type="none" w="med" len="med"/>
+                      <a:tailEnd type="none" w="med" len="med"/>
+                    </a:lnL>
+                    <a:lnR w="9525" cap="flat" cmpd="sng" algn="ctr">
+                      <a:solidFill>
+                        <a:srgbClr val="D9D9D9"/>
+                      </a:solidFill>
+                      <a:prstDash val="solid"/>
+                      <a:round/>
+                      <a:headEnd type="none" w="med" len="med"/>
+                      <a:tailEnd type="none" w="med" len="med"/>
+                    </a:lnR>
+                    <a:lnT w="9525" cap="flat" cmpd="sng" algn="ctr">
+                      <a:solidFill>
+                        <a:srgbClr val="D9D9D9"/>
+                      </a:solidFill>
+                      <a:prstDash val="solid"/>
+                      <a:round/>
+                      <a:headEnd type="none" w="med" len="med"/>
+                      <a:tailEnd type="none" w="med" len="med"/>
+                    </a:lnT>
+                    <a:lnB w="9525" cap="flat" cmpd="sng" algn="ctr">
+                      <a:solidFill>
+                        <a:srgbClr val="D9D9D9"/>
+                      </a:solidFill>
+                      <a:prstDash val="solid"/>
+                      <a:round/>
+                      <a:headEnd type="none" w="med" len="med"/>
+                      <a:tailEnd type="none" w="med" len="med"/>
+                    </a:lnB>
+                  </a:tcPr>
+                </a:tc>
+              </a:tr>
+              <a:tr h="548640">
+                <a:tc>
+                  <a:txBody>
+                    <a:bodyPr/>
+                    <a:lstStyle/>
+                    <a:p>
+                      <a:pPr indent="0" marL="0">
+                        <a:buNone/>
+                      </a:pPr>
+                      <a:r>
+                        <a:rPr lang="en-US" sz="1500" dirty="0">
+                          <a:solidFill>
+                            <a:srgbClr val="000000"/>
+                          </a:solidFill>
+                          <a:latin typeface="Calibri" pitchFamily="34" charset="0"/>
+                          <a:ea typeface="Calibri" pitchFamily="34" charset="-122"/>
+                          <a:cs typeface="Calibri" pitchFamily="34" charset="-120"/>
+                        </a:rPr>
+                        <a:t>Nov 14 – Nov 21</a:t>
+                      </a:r>
+                      <a:endParaRPr lang="en-US" sz="1500" dirty="0">
+                        <a:latin typeface="Calibri" charset="0"/>
+                        <a:ea typeface="Calibri" charset="0"/>
+                        <a:cs typeface="Calibri" charset="0"/>
+                      </a:endParaRPr>
+                    </a:p>
+                  </a:txBody>
+                  <a:tcPr marL="91440" marR="91440" marT="45720" marB="45720" anchor="ctr">
+                    <a:lnL w="9525" cap="flat" cmpd="sng" algn="ctr">
+                      <a:solidFill>
+                        <a:srgbClr val="D9D9D9"/>
+                      </a:solidFill>
+                      <a:prstDash val="solid"/>
+                      <a:round/>
+                      <a:headEnd type="none" w="med" len="med"/>
+                      <a:tailEnd type="none" w="med" len="med"/>
+                    </a:lnL>
+                    <a:lnR w="9525" cap="flat" cmpd="sng" algn="ctr">
+                      <a:solidFill>
+                        <a:srgbClr val="D9D9D9"/>
+                      </a:solidFill>
+                      <a:prstDash val="solid"/>
+                      <a:round/>
+                      <a:headEnd type="none" w="med" len="med"/>
+                      <a:tailEnd type="none" w="med" len="med"/>
+                    </a:lnR>
+                    <a:lnT w="9525" cap="flat" cmpd="sng" algn="ctr">
+                      <a:solidFill>
+                        <a:srgbClr val="D9D9D9"/>
+                      </a:solidFill>
+                      <a:prstDash val="solid"/>
+                      <a:round/>
+                      <a:headEnd type="none" w="med" len="med"/>
+                      <a:tailEnd type="none" w="med" len="med"/>
+                    </a:lnT>
+                    <a:lnB w="9525" cap="flat" cmpd="sng" algn="ctr">
+                      <a:solidFill>
+                        <a:srgbClr val="D9D9D9"/>
+                      </a:solidFill>
+                      <a:prstDash val="solid"/>
+                      <a:round/>
+                      <a:headEnd type="none" w="med" len="med"/>
+                      <a:tailEnd type="none" w="med" len="med"/>
+                    </a:lnB>
+                  </a:tcPr>
+                </a:tc>
+                <a:tc>
+                  <a:txBody>
+                    <a:bodyPr/>
+                    <a:lstStyle/>
+                    <a:p>
+                      <a:pPr indent="0" marL="0">
+                        <a:buNone/>
+                      </a:pPr>
+                      <a:r>
+                        <a:rPr lang="en-US" sz="1500" dirty="0">
+                          <a:solidFill>
+                            <a:srgbClr val="000000"/>
+                          </a:solidFill>
+                          <a:latin typeface="Calibri" pitchFamily="34" charset="0"/>
+                          <a:ea typeface="Calibri" pitchFamily="34" charset="-122"/>
+                          <a:cs typeface="Calibri" pitchFamily="34" charset="-120"/>
+                        </a:rPr>
+                        <a:t>Write the short conference-formatted paper</a:t>
+                      </a:r>
+                      <a:endParaRPr lang="en-US" sz="1500" dirty="0">
+                        <a:latin typeface="Calibri" charset="0"/>
+                        <a:ea typeface="Calibri" charset="0"/>
+                        <a:cs typeface="Calibri" charset="0"/>
+                      </a:endParaRPr>
+                    </a:p>
+                  </a:txBody>
+                  <a:tcPr marL="91440" marR="91440" marT="45720" marB="45720" anchor="ctr">
+                    <a:lnL w="9525" cap="flat" cmpd="sng" algn="ctr">
+                      <a:solidFill>
+                        <a:srgbClr val="D9D9D9"/>
+                      </a:solidFill>
+                      <a:prstDash val="solid"/>
+                      <a:round/>
+                      <a:headEnd type="none" w="med" len="med"/>
+                      <a:tailEnd type="none" w="med" len="med"/>
+                    </a:lnL>
+                    <a:lnR w="9525" cap="flat" cmpd="sng" algn="ctr">
+                      <a:solidFill>
+                        <a:srgbClr val="D9D9D9"/>
+                      </a:solidFill>
+                      <a:prstDash val="solid"/>
+                      <a:round/>
+                      <a:headEnd type="none" w="med" len="med"/>
+                      <a:tailEnd type="none" w="med" len="med"/>
+                    </a:lnR>
+                    <a:lnT w="9525" cap="flat" cmpd="sng" algn="ctr">
+                      <a:solidFill>
+                        <a:srgbClr val="D9D9D9"/>
+                      </a:solidFill>
+                      <a:prstDash val="solid"/>
+                      <a:round/>
+                      <a:headEnd type="none" w="med" len="med"/>
+                      <a:tailEnd type="none" w="med" len="med"/>
+                    </a:lnT>
+                    <a:lnB w="9525" cap="flat" cmpd="sng" algn="ctr">
+                      <a:solidFill>
+                        <a:srgbClr val="D9D9D9"/>
+                      </a:solidFill>
+                      <a:prstDash val="solid"/>
+                      <a:round/>
+                      <a:headEnd type="none" w="med" len="med"/>
+                      <a:tailEnd type="none" w="med" len="med"/>
+                    </a:lnB>
+                  </a:tcPr>
+                </a:tc>
+              </a:tr>
+              <a:tr h="548640">
+                <a:tc>
+                  <a:txBody>
+                    <a:bodyPr/>
+                    <a:lstStyle/>
+                    <a:p>
+                      <a:pPr indent="0" marL="0">
+                        <a:buNone/>
+                      </a:pPr>
+                      <a:r>
+                        <a:rPr lang="en-US" sz="1500" dirty="0">
+                          <a:solidFill>
+                            <a:srgbClr val="000000"/>
+                          </a:solidFill>
+                          <a:latin typeface="Calibri" pitchFamily="34" charset="0"/>
+                          <a:ea typeface="Calibri" pitchFamily="34" charset="-122"/>
+                          <a:cs typeface="Calibri" pitchFamily="34" charset="-120"/>
+                        </a:rPr>
+                        <a:t>Nov 21 – Nov 30</a:t>
+                      </a:r>
+                      <a:endParaRPr lang="en-US" sz="1500" dirty="0">
+                        <a:latin typeface="Calibri" charset="0"/>
+                        <a:ea typeface="Calibri" charset="0"/>
+                        <a:cs typeface="Calibri" charset="0"/>
+                      </a:endParaRPr>
+                    </a:p>
+                  </a:txBody>
+                  <a:tcPr marL="91440" marR="91440" marT="45720" marB="45720" anchor="ctr">
+                    <a:lnL w="9525" cap="flat" cmpd="sng" algn="ctr">
+                      <a:solidFill>
+                        <a:srgbClr val="D9D9D9"/>
+                      </a:solidFill>
+                      <a:prstDash val="solid"/>
+                      <a:round/>
+                      <a:headEnd type="none" w="med" len="med"/>
+                      <a:tailEnd type="none" w="med" len="med"/>
+                    </a:lnL>
+                    <a:lnR w="9525" cap="flat" cmpd="sng" algn="ctr">
+                      <a:solidFill>
+                        <a:srgbClr val="D9D9D9"/>
+                      </a:solidFill>
+                      <a:prstDash val="solid"/>
+                      <a:round/>
+                      <a:headEnd type="none" w="med" len="med"/>
+                      <a:tailEnd type="none" w="med" len="med"/>
+                    </a:lnR>
+                    <a:lnT w="9525" cap="flat" cmpd="sng" algn="ctr">
+                      <a:solidFill>
+                        <a:srgbClr val="D9D9D9"/>
+                      </a:solidFill>
+                      <a:prstDash val="solid"/>
+                      <a:round/>
+                      <a:headEnd type="none" w="med" len="med"/>
+                      <a:tailEnd type="none" w="med" len="med"/>
+                    </a:lnT>
+                    <a:lnB w="9525" cap="flat" cmpd="sng" algn="ctr">
+                      <a:solidFill>
+                        <a:srgbClr val="D9D9D9"/>
+                      </a:solidFill>
+                      <a:prstDash val="solid"/>
+                      <a:round/>
+                      <a:headEnd type="none" w="med" len="med"/>
+                      <a:tailEnd type="none" w="med" len="med"/>
+                    </a:lnB>
+                  </a:tcPr>
+                </a:tc>
+                <a:tc>
+                  <a:txBody>
+                    <a:bodyPr/>
+                    <a:lstStyle/>
+                    <a:p>
+                      <a:pPr indent="0" marL="0">
+                        <a:buNone/>
+                      </a:pPr>
+                      <a:r>
+                        <a:rPr lang="en-US" sz="1500" dirty="0">
+                          <a:solidFill>
+                            <a:srgbClr val="000000"/>
+                          </a:solidFill>
+                          <a:latin typeface="Calibri" pitchFamily="34" charset="0"/>
+                          <a:ea typeface="Calibri" pitchFamily="34" charset="-122"/>
+                          <a:cs typeface="Calibri" pitchFamily="34" charset="-120"/>
+                        </a:rPr>
+                        <a:t>Finalize paper; prepare final presentation</a:t>
+                      </a:r>
+                      <a:endParaRPr lang="en-US" sz="1500" dirty="0">
+                        <a:latin typeface="Calibri" charset="0"/>
+                        <a:ea typeface="Calibri" charset="0"/>
+                        <a:cs typeface="Calibri" charset="0"/>
+                      </a:endParaRPr>
+                    </a:p>
+                  </a:txBody>
+                  <a:tcPr marL="91440" marR="91440" marT="45720" marB="45720" anchor="ctr">
+                    <a:lnL w="9525" cap="flat" cmpd="sng" algn="ctr">
+                      <a:solidFill>
+                        <a:srgbClr val="D9D9D9"/>
+                      </a:solidFill>
+                      <a:prstDash val="solid"/>
+                      <a:round/>
+                      <a:headEnd type="none" w="med" len="med"/>
+                      <a:tailEnd type="none" w="med" len="med"/>
+                    </a:lnL>
+                    <a:lnR w="9525" cap="flat" cmpd="sng" algn="ctr">
+                      <a:solidFill>
+                        <a:srgbClr val="D9D9D9"/>
+                      </a:solidFill>
+                      <a:prstDash val="solid"/>
+                      <a:round/>
+                      <a:headEnd type="none" w="med" len="med"/>
+                      <a:tailEnd type="none" w="med" len="med"/>
+                    </a:lnR>
+                    <a:lnT w="9525" cap="flat" cmpd="sng" algn="ctr">
+                      <a:solidFill>
+                        <a:srgbClr val="D9D9D9"/>
+                      </a:solidFill>
+                      <a:prstDash val="solid"/>
+                      <a:round/>
+                      <a:headEnd type="none" w="med" len="med"/>
+                      <a:tailEnd type="none" w="med" len="med"/>
+                    </a:lnT>
+                    <a:lnB w="9525" cap="flat" cmpd="sng" algn="ctr">
+                      <a:solidFill>
+                        <a:srgbClr val="D9D9D9"/>
+                      </a:solidFill>
+                      <a:prstDash val="solid"/>
+                      <a:round/>
+                      <a:headEnd type="none" w="med" len="med"/>
+                      <a:tailEnd type="none" w="med" len="med"/>
+                    </a:lnB>
+                  </a:tcPr>
+                </a:tc>
+              </a:tr>
+              <a:tr h="548640">
+                <a:tc>
+                  <a:txBody>
+                    <a:bodyPr/>
+                    <a:lstStyle/>
+                    <a:p>
+                      <a:pPr indent="0" marL="0">
+                        <a:buNone/>
+                      </a:pPr>
+                      <a:r>
+                        <a:rPr lang="en-US" sz="1500" dirty="0">
+                          <a:solidFill>
+                            <a:srgbClr val="000000"/>
+                          </a:solidFill>
+                          <a:latin typeface="Calibri" pitchFamily="34" charset="0"/>
+                          <a:ea typeface="Calibri" pitchFamily="34" charset="-122"/>
+                          <a:cs typeface="Calibri" pitchFamily="34" charset="-120"/>
+                        </a:rPr>
+                        <a:t>Dec 2</a:t>
+                      </a:r>
+                      <a:endParaRPr lang="en-US" sz="1500" dirty="0">
+                        <a:latin typeface="Calibri" charset="0"/>
+                        <a:ea typeface="Calibri" charset="0"/>
+                        <a:cs typeface="Calibri" charset="0"/>
+                      </a:endParaRPr>
+                    </a:p>
+                  </a:txBody>
+                  <a:tcPr marL="91440" marR="91440" marT="45720" marB="45720" anchor="ctr">
+                    <a:lnL w="9525" cap="flat" cmpd="sng" algn="ctr">
+                      <a:solidFill>
+                        <a:srgbClr val="D9D9D9"/>
+                      </a:solidFill>
+                      <a:prstDash val="solid"/>
+                      <a:round/>
+                      <a:headEnd type="none" w="med" len="med"/>
+                      <a:tailEnd type="none" w="med" len="med"/>
+                    </a:lnL>
+                    <a:lnR w="9525" cap="flat" cmpd="sng" algn="ctr">
+                      <a:solidFill>
+                        <a:srgbClr val="D9D9D9"/>
+                      </a:solidFill>
+                      <a:prstDash val="solid"/>
+                      <a:round/>
+                      <a:headEnd type="none" w="med" len="med"/>
+                      <a:tailEnd type="none" w="med" len="med"/>
+                    </a:lnR>
+                    <a:lnT w="9525" cap="flat" cmpd="sng" algn="ctr">
+                      <a:solidFill>
+                        <a:srgbClr val="D9D9D9"/>
+                      </a:solidFill>
+                      <a:prstDash val="solid"/>
+                      <a:round/>
+                      <a:headEnd type="none" w="med" len="med"/>
+                      <a:tailEnd type="none" w="med" len="med"/>
+                    </a:lnT>
+                    <a:lnB w="9525" cap="flat" cmpd="sng" algn="ctr">
+                      <a:solidFill>
+                        <a:srgbClr val="D9D9D9"/>
+                      </a:solidFill>
+                      <a:prstDash val="solid"/>
+                      <a:round/>
+                      <a:headEnd type="none" w="med" len="med"/>
+                      <a:tailEnd type="none" w="med" len="med"/>
+                    </a:lnB>
+                  </a:tcPr>
+                </a:tc>
+                <a:tc>
+                  <a:txBody>
+                    <a:bodyPr/>
+                    <a:lstStyle/>
+                    <a:p>
+                      <a:pPr indent="0" marL="0">
+                        <a:buNone/>
+                      </a:pPr>
+                      <a:r>
+                        <a:rPr lang="en-US" sz="1500" dirty="0">
+                          <a:solidFill>
+                            <a:srgbClr val="000000"/>
+                          </a:solidFill>
+                          <a:latin typeface="Calibri" pitchFamily="34" charset="0"/>
+                          <a:ea typeface="Calibri" pitchFamily="34" charset="-122"/>
+                          <a:cs typeface="Calibri" pitchFamily="34" charset="-120"/>
+                        </a:rPr>
+                        <a:t>Final presentation and paper submission (last day of classes)</a:t>
+                      </a:r>
+                      <a:endParaRPr lang="en-US" sz="1500" dirty="0">
+                        <a:latin typeface="Calibri" charset="0"/>
+                        <a:ea typeface="Calibri" charset="0"/>
+                        <a:cs typeface="Calibri" charset="0"/>
+                      </a:endParaRPr>
+                    </a:p>
+                  </a:txBody>
+                  <a:tcPr marL="91440" marR="91440" marT="45720" marB="45720" anchor="ctr">
+                    <a:lnL w="9525" cap="flat" cmpd="sng" algn="ctr">
+                      <a:solidFill>
+                        <a:srgbClr val="D9D9D9"/>
+                      </a:solidFill>
+                      <a:prstDash val="solid"/>
+                      <a:round/>
+                      <a:headEnd type="none" w="med" len="med"/>
+                      <a:tailEnd type="none" w="med" len="med"/>
+                    </a:lnL>
+                    <a:lnR w="9525" cap="flat" cmpd="sng" algn="ctr">
+                      <a:solidFill>
+                        <a:srgbClr val="D9D9D9"/>
+                      </a:solidFill>
+                      <a:prstDash val="solid"/>
+                      <a:round/>
+                      <a:headEnd type="none" w="med" len="med"/>
+                      <a:tailEnd type="none" w="med" len="med"/>
+                    </a:lnR>
+                    <a:lnT w="9525" cap="flat" cmpd="sng" algn="ctr">
+                      <a:solidFill>
+                        <a:srgbClr val="D9D9D9"/>
+                      </a:solidFill>
+                      <a:prstDash val="solid"/>
+                      <a:round/>
+                      <a:headEnd type="none" w="med" len="med"/>
+                      <a:tailEnd type="none" w="med" len="med"/>
+                    </a:lnT>
+                    <a:lnB w="9525" cap="flat" cmpd="sng" algn="ctr">
+                      <a:solidFill>
+                        <a:srgbClr val="D9D9D9"/>
+                      </a:solidFill>
+                      <a:prstDash val="solid"/>
+                      <a:round/>
+                      <a:headEnd type="none" w="med" len="med"/>
+                      <a:tailEnd type="none" w="med" len="med"/>
+                    </a:lnB>
+                  </a:tcPr>
+                </a:tc>
+              </a:tr>
+            </a:tbl>
+          </a:graphicData>
+        </a:graphic>
+      </p:graphicFrame>
+      <p:sp>
+        <p:nvSpPr>
+          <p:cNvPr id="5" name="Text 2"/>
+          <p:cNvSpPr txBox="1"/>
+          <p:nvPr/>
+        </p:nvSpPr>
+        <p:spPr>
+          <a:xfrm>
+            <a:off x="11457432" y="6446520"/>
+            <a:ext cx="457200" cy="274320"/>
+          </a:xfrm>
+          <a:prstGeom prst="rect">
+            <a:avLst/>
+          </a:prstGeom>
+          <a:noFill/>
+          <a:ln/>
+        </p:spPr>
+        <p:txBody>
+          <a:bodyPr wrap="square" rtlCol="0" anchor="ctr"/>
+          <a:lstStyle/>
+          <a:p>
+            <a:pPr algn="r" indent="0" marL="0">
+              <a:buNone/>
+            </a:pPr>
+            <a:r>
+              <a:rPr lang="en-US" sz="1000" dirty="0">
+                <a:solidFill>
+                  <a:srgbClr val="595959"/>
+                </a:solidFill>
+                <a:latin typeface="Calibri" pitchFamily="34" charset="0"/>
+                <a:ea typeface="Calibri" pitchFamily="34" charset="-122"/>
+                <a:cs typeface="Calibri" pitchFamily="34" charset="-120"/>
+              </a:rPr>
+              <a:t>9</a:t>
             </a:r>
             <a:endParaRPr lang="en-US" sz="1000" dirty="0"/>
           </a:p>

</xml_diff>